<commit_message>
Redesigned presentation + training augmentation
- Presentation: navy/azure/coral theme, architecture block diagram,
  big before/after iteration visual, stat tiles, spectrogram title art,
  speaker notes on all 13 slides, slide footers
- Training: new src/augment.py (time shift, background-noise mixing,
  SpecAugment), --augment/--weighted/--amp flags in train.py
- Backup of the 63.3% baseline checkpoint kept in models/backup_baseline/
</commit_message>
<xml_diff>
--- a/presentation/voice_command_recognition.pptx
+++ b/presentation/voice_command_recognition.pptx
@@ -6,18 +6,18 @@
   </p:sldMasterIdLst>
   <p:sldIdLst>
     <p:sldId id="256" r:id="rId7"/>
-    <p:sldId id="257" r:id="rId8"/>
-    <p:sldId id="258" r:id="rId9"/>
-    <p:sldId id="259" r:id="rId10"/>
-    <p:sldId id="260" r:id="rId11"/>
-    <p:sldId id="261" r:id="rId12"/>
-    <p:sldId id="262" r:id="rId13"/>
-    <p:sldId id="263" r:id="rId14"/>
-    <p:sldId id="264" r:id="rId15"/>
-    <p:sldId id="265" r:id="rId16"/>
-    <p:sldId id="266" r:id="rId17"/>
-    <p:sldId id="267" r:id="rId18"/>
-    <p:sldId id="268" r:id="rId19"/>
+    <p:sldId id="257" r:id="rId9"/>
+    <p:sldId id="258" r:id="rId10"/>
+    <p:sldId id="259" r:id="rId11"/>
+    <p:sldId id="260" r:id="rId12"/>
+    <p:sldId id="261" r:id="rId13"/>
+    <p:sldId id="262" r:id="rId14"/>
+    <p:sldId id="263" r:id="rId15"/>
+    <p:sldId id="264" r:id="rId16"/>
+    <p:sldId id="265" r:id="rId17"/>
+    <p:sldId id="266" r:id="rId18"/>
+    <p:sldId id="267" r:id="rId19"/>
+    <p:sldId id="268" r:id="rId20"/>
   </p:sldIdLst>
   <p:sldSz cx="12191695" cy="6858000" type="screen4x3"/>
   <p:notesSz cx="6858000" cy="9144000"/>
@@ -117,6 +117,1266 @@
     </a:lvl9pPr>
   </p:defaultTextStyle>
 </p:presentation>
+</file>
+
+<file path=ppt/notesMasters/notesMaster1.xml><?xml version="1.0" encoding="utf-8"?>
+<p:notesMaster xmlns:a="http://schemas.openxmlformats.org/drawingml/2006/main" xmlns:p="http://schemas.openxmlformats.org/presentationml/2006/main" xmlns:r="http://schemas.openxmlformats.org/officeDocument/2006/relationships">
+  <p:cSld>
+    <p:bg>
+      <p:bgRef idx="1001">
+        <a:schemeClr val="bg1"/>
+      </p:bgRef>
+    </p:bg>
+    <p:spTree>
+      <p:nvGrpSpPr>
+        <p:cNvPr id="1" name=""/>
+        <p:cNvGrpSpPr/>
+        <p:nvPr/>
+      </p:nvGrpSpPr>
+      <p:grpSpPr>
+        <a:xfrm>
+          <a:off x="0" y="0"/>
+          <a:ext cx="0" cy="0"/>
+          <a:chOff x="0" y="0"/>
+          <a:chExt cx="0" cy="0"/>
+        </a:xfrm>
+      </p:grpSpPr>
+      <p:sp>
+        <p:nvSpPr>
+          <p:cNvPr id="2" name="Header Placeholder 1"/>
+          <p:cNvSpPr>
+            <a:spLocks noGrp="1"/>
+          </p:cNvSpPr>
+          <p:nvPr>
+            <p:ph type="hdr" sz="quarter"/>
+          </p:nvPr>
+        </p:nvSpPr>
+        <p:spPr>
+          <a:xfrm>
+            <a:off x="0" y="0"/>
+            <a:ext cx="2971800" cy="457200"/>
+          </a:xfrm>
+          <a:prstGeom prst="rect">
+            <a:avLst/>
+          </a:prstGeom>
+        </p:spPr>
+        <p:txBody>
+          <a:bodyPr vert="horz" lIns="91440" tIns="45720" rIns="91440" bIns="45720" rtlCol="0"/>
+          <a:lstStyle>
+            <a:lvl1pPr algn="l">
+              <a:defRPr sz="1200"/>
+            </a:lvl1pPr>
+          </a:lstStyle>
+          <a:p>
+            <a:endParaRPr lang="en-US"/>
+          </a:p>
+        </p:txBody>
+      </p:sp>
+      <p:sp>
+        <p:nvSpPr>
+          <p:cNvPr id="3" name="Date Placeholder 2"/>
+          <p:cNvSpPr>
+            <a:spLocks noGrp="1"/>
+          </p:cNvSpPr>
+          <p:nvPr>
+            <p:ph type="dt" idx="1"/>
+          </p:nvPr>
+        </p:nvSpPr>
+        <p:spPr>
+          <a:xfrm>
+            <a:off x="3884613" y="0"/>
+            <a:ext cx="2971800" cy="457200"/>
+          </a:xfrm>
+          <a:prstGeom prst="rect">
+            <a:avLst/>
+          </a:prstGeom>
+        </p:spPr>
+        <p:txBody>
+          <a:bodyPr vert="horz" lIns="91440" tIns="45720" rIns="91440" bIns="45720" rtlCol="0"/>
+          <a:lstStyle>
+            <a:lvl1pPr algn="r">
+              <a:defRPr sz="1200"/>
+            </a:lvl1pPr>
+          </a:lstStyle>
+          <a:p>
+            <a:fld id="{0F89C1C7-3DCD-1040-A9CF-14679D8B5DDD}" type="datetimeFigureOut">
+              <a:rPr lang="en-US" smtClean="0"/>
+              <a:t>10/17/16</a:t>
+            </a:fld>
+            <a:endParaRPr lang="en-US"/>
+          </a:p>
+        </p:txBody>
+      </p:sp>
+      <p:sp>
+        <p:nvSpPr>
+          <p:cNvPr id="4" name="Slide Image Placeholder 3"/>
+          <p:cNvSpPr>
+            <a:spLocks noGrp="1" noRot="1" noChangeAspect="1"/>
+          </p:cNvSpPr>
+          <p:nvPr>
+            <p:ph type="sldImg" idx="2"/>
+          </p:nvPr>
+        </p:nvSpPr>
+        <p:spPr>
+          <a:xfrm>
+            <a:off x="1143000" y="685800"/>
+            <a:ext cx="4572000" cy="3429000"/>
+          </a:xfrm>
+          <a:prstGeom prst="rect">
+            <a:avLst/>
+          </a:prstGeom>
+          <a:noFill/>
+          <a:ln w="12700">
+            <a:solidFill>
+              <a:prstClr val="black"/>
+            </a:solidFill>
+          </a:ln>
+        </p:spPr>
+        <p:txBody>
+          <a:bodyPr vert="horz" lIns="91440" tIns="45720" rIns="91440" bIns="45720" rtlCol="0" anchor="ctr"/>
+          <a:lstStyle/>
+          <a:p>
+            <a:endParaRPr lang="en-US"/>
+          </a:p>
+        </p:txBody>
+      </p:sp>
+      <p:sp>
+        <p:nvSpPr>
+          <p:cNvPr id="5" name="Notes Placeholder 4"/>
+          <p:cNvSpPr>
+            <a:spLocks noGrp="1"/>
+          </p:cNvSpPr>
+          <p:nvPr>
+            <p:ph type="body" sz="quarter" idx="3"/>
+          </p:nvPr>
+        </p:nvSpPr>
+        <p:spPr>
+          <a:xfrm>
+            <a:off x="685800" y="4343400"/>
+            <a:ext cx="5486400" cy="4114800"/>
+          </a:xfrm>
+          <a:prstGeom prst="rect">
+            <a:avLst/>
+          </a:prstGeom>
+        </p:spPr>
+        <p:txBody>
+          <a:bodyPr vert="horz" lIns="91440" tIns="45720" rIns="91440" bIns="45720" rtlCol="0"/>
+          <a:lstStyle/>
+          <a:p>
+            <a:pPr lvl="0"/>
+            <a:r>
+              <a:rPr lang="en-US" smtClean="0"/>
+              <a:t>Click to edit Master text styles</a:t>
+            </a:r>
+          </a:p>
+          <a:p>
+            <a:pPr lvl="1"/>
+            <a:r>
+              <a:rPr lang="en-US" smtClean="0"/>
+              <a:t>Second level</a:t>
+            </a:r>
+          </a:p>
+          <a:p>
+            <a:pPr lvl="2"/>
+            <a:r>
+              <a:rPr lang="en-US" smtClean="0"/>
+              <a:t>Third level</a:t>
+            </a:r>
+          </a:p>
+          <a:p>
+            <a:pPr lvl="3"/>
+            <a:r>
+              <a:rPr lang="en-US" smtClean="0"/>
+              <a:t>Fourth level</a:t>
+            </a:r>
+          </a:p>
+          <a:p>
+            <a:pPr lvl="4"/>
+            <a:r>
+              <a:rPr lang="en-US" smtClean="0"/>
+              <a:t>Fifth level</a:t>
+            </a:r>
+            <a:endParaRPr lang="en-US"/>
+          </a:p>
+        </p:txBody>
+      </p:sp>
+      <p:sp>
+        <p:nvSpPr>
+          <p:cNvPr id="6" name="Footer Placeholder 5"/>
+          <p:cNvSpPr>
+            <a:spLocks noGrp="1"/>
+          </p:cNvSpPr>
+          <p:nvPr>
+            <p:ph type="ftr" sz="quarter" idx="4"/>
+          </p:nvPr>
+        </p:nvSpPr>
+        <p:spPr>
+          <a:xfrm>
+            <a:off x="0" y="8685213"/>
+            <a:ext cx="2971800" cy="457200"/>
+          </a:xfrm>
+          <a:prstGeom prst="rect">
+            <a:avLst/>
+          </a:prstGeom>
+        </p:spPr>
+        <p:txBody>
+          <a:bodyPr vert="horz" lIns="91440" tIns="45720" rIns="91440" bIns="45720" rtlCol="0" anchor="b"/>
+          <a:lstStyle>
+            <a:lvl1pPr algn="l">
+              <a:defRPr sz="1200"/>
+            </a:lvl1pPr>
+          </a:lstStyle>
+          <a:p>
+            <a:endParaRPr lang="en-US"/>
+          </a:p>
+        </p:txBody>
+      </p:sp>
+      <p:sp>
+        <p:nvSpPr>
+          <p:cNvPr id="7" name="Slide Number Placeholder 6"/>
+          <p:cNvSpPr>
+            <a:spLocks noGrp="1"/>
+          </p:cNvSpPr>
+          <p:nvPr>
+            <p:ph type="sldNum" sz="quarter" idx="5"/>
+          </p:nvPr>
+        </p:nvSpPr>
+        <p:spPr>
+          <a:xfrm>
+            <a:off x="3884613" y="8685213"/>
+            <a:ext cx="2971800" cy="457200"/>
+          </a:xfrm>
+          <a:prstGeom prst="rect">
+            <a:avLst/>
+          </a:prstGeom>
+        </p:spPr>
+        <p:txBody>
+          <a:bodyPr vert="horz" lIns="91440" tIns="45720" rIns="91440" bIns="45720" rtlCol="0" anchor="b"/>
+          <a:lstStyle>
+            <a:lvl1pPr algn="r">
+              <a:defRPr sz="1200"/>
+            </a:lvl1pPr>
+          </a:lstStyle>
+          <a:p>
+            <a:fld id="{BB5E49A5-4136-284D-997B-48E1D791AD67}" type="slidenum">
+              <a:rPr lang="en-US" smtClean="0"/>
+              <a:t>‹#›</a:t>
+            </a:fld>
+            <a:endParaRPr lang="en-US"/>
+          </a:p>
+        </p:txBody>
+      </p:sp>
+    </p:spTree>
+    <p:extLst>
+      <p:ext uri="{BB962C8B-B14F-4D97-AF65-F5344CB8AC3E}">
+        <p14:creationId xmlns:p14="http://schemas.microsoft.com/office/powerpoint/2010/main" val="2623252185"/>
+      </p:ext>
+    </p:extLst>
+  </p:cSld>
+  <p:clrMap bg1="lt1" tx1="dk1" bg2="lt2" tx2="dk2" accent1="accent1" accent2="accent2" accent3="accent3" accent4="accent4" accent5="accent5" accent6="accent6" hlink="hlink" folHlink="folHlink"/>
+  <p:notesStyle>
+    <a:lvl1pPr marL="0" algn="l" defTabSz="457200" rtl="0" eaLnBrk="1" latinLnBrk="0" hangingPunct="1">
+      <a:defRPr sz="1200" kern="1200">
+        <a:solidFill>
+          <a:schemeClr val="tx1"/>
+        </a:solidFill>
+        <a:latin typeface="+mn-lt"/>
+        <a:ea typeface="+mn-ea"/>
+        <a:cs typeface="+mn-cs"/>
+      </a:defRPr>
+    </a:lvl1pPr>
+    <a:lvl2pPr marL="457200" algn="l" defTabSz="457200" rtl="0" eaLnBrk="1" latinLnBrk="0" hangingPunct="1">
+      <a:defRPr sz="1200" kern="1200">
+        <a:solidFill>
+          <a:schemeClr val="tx1"/>
+        </a:solidFill>
+        <a:latin typeface="+mn-lt"/>
+        <a:ea typeface="+mn-ea"/>
+        <a:cs typeface="+mn-cs"/>
+      </a:defRPr>
+    </a:lvl2pPr>
+    <a:lvl3pPr marL="914400" algn="l" defTabSz="457200" rtl="0" eaLnBrk="1" latinLnBrk="0" hangingPunct="1">
+      <a:defRPr sz="1200" kern="1200">
+        <a:solidFill>
+          <a:schemeClr val="tx1"/>
+        </a:solidFill>
+        <a:latin typeface="+mn-lt"/>
+        <a:ea typeface="+mn-ea"/>
+        <a:cs typeface="+mn-cs"/>
+      </a:defRPr>
+    </a:lvl3pPr>
+    <a:lvl4pPr marL="1371600" algn="l" defTabSz="457200" rtl="0" eaLnBrk="1" latinLnBrk="0" hangingPunct="1">
+      <a:defRPr sz="1200" kern="1200">
+        <a:solidFill>
+          <a:schemeClr val="tx1"/>
+        </a:solidFill>
+        <a:latin typeface="+mn-lt"/>
+        <a:ea typeface="+mn-ea"/>
+        <a:cs typeface="+mn-cs"/>
+      </a:defRPr>
+    </a:lvl4pPr>
+    <a:lvl5pPr marL="1828800" algn="l" defTabSz="457200" rtl="0" eaLnBrk="1" latinLnBrk="0" hangingPunct="1">
+      <a:defRPr sz="1200" kern="1200">
+        <a:solidFill>
+          <a:schemeClr val="tx1"/>
+        </a:solidFill>
+        <a:latin typeface="+mn-lt"/>
+        <a:ea typeface="+mn-ea"/>
+        <a:cs typeface="+mn-cs"/>
+      </a:defRPr>
+    </a:lvl5pPr>
+    <a:lvl6pPr marL="2286000" algn="l" defTabSz="457200" rtl="0" eaLnBrk="1" latinLnBrk="0" hangingPunct="1">
+      <a:defRPr sz="1200" kern="1200">
+        <a:solidFill>
+          <a:schemeClr val="tx1"/>
+        </a:solidFill>
+        <a:latin typeface="+mn-lt"/>
+        <a:ea typeface="+mn-ea"/>
+        <a:cs typeface="+mn-cs"/>
+      </a:defRPr>
+    </a:lvl6pPr>
+    <a:lvl7pPr marL="2743200" algn="l" defTabSz="457200" rtl="0" eaLnBrk="1" latinLnBrk="0" hangingPunct="1">
+      <a:defRPr sz="1200" kern="1200">
+        <a:solidFill>
+          <a:schemeClr val="tx1"/>
+        </a:solidFill>
+        <a:latin typeface="+mn-lt"/>
+        <a:ea typeface="+mn-ea"/>
+        <a:cs typeface="+mn-cs"/>
+      </a:defRPr>
+    </a:lvl7pPr>
+    <a:lvl8pPr marL="3200400" algn="l" defTabSz="457200" rtl="0" eaLnBrk="1" latinLnBrk="0" hangingPunct="1">
+      <a:defRPr sz="1200" kern="1200">
+        <a:solidFill>
+          <a:schemeClr val="tx1"/>
+        </a:solidFill>
+        <a:latin typeface="+mn-lt"/>
+        <a:ea typeface="+mn-ea"/>
+        <a:cs typeface="+mn-cs"/>
+      </a:defRPr>
+    </a:lvl8pPr>
+    <a:lvl9pPr marL="3657600" algn="l" defTabSz="457200" rtl="0" eaLnBrk="1" latinLnBrk="0" hangingPunct="1">
+      <a:defRPr sz="1200" kern="1200">
+        <a:solidFill>
+          <a:schemeClr val="tx1"/>
+        </a:solidFill>
+        <a:latin typeface="+mn-lt"/>
+        <a:ea typeface="+mn-ea"/>
+        <a:cs typeface="+mn-cs"/>
+      </a:defRPr>
+    </a:lvl9pPr>
+  </p:notesStyle>
+</p:notesMaster>
+</file>
+
+<file path=ppt/notesSlides/notesSlide1.xml><?xml version="1.0" encoding="utf-8"?>
+<p:notes xmlns:a="http://schemas.openxmlformats.org/drawingml/2006/main" xmlns:p="http://schemas.openxmlformats.org/presentationml/2006/main" xmlns:r="http://schemas.openxmlformats.org/officeDocument/2006/relationships">
+  <p:cSld>
+    <p:spTree>
+      <p:nvGrpSpPr>
+        <p:cNvPr id="1" name=""/>
+        <p:cNvGrpSpPr/>
+        <p:nvPr/>
+      </p:nvGrpSpPr>
+      <p:grpSpPr>
+        <a:xfrm>
+          <a:off x="0" y="0"/>
+          <a:ext cx="0" cy="0"/>
+          <a:chOff x="0" y="0"/>
+          <a:chExt cx="0" cy="0"/>
+        </a:xfrm>
+      </p:grpSpPr>
+      <p:sp>
+        <p:nvSpPr>
+          <p:cNvPr id="2" name="Slide Image Placeholder 1"/>
+          <p:cNvSpPr>
+            <a:spLocks noGrp="1"/>
+          </p:cNvSpPr>
+          <p:nvPr>
+            <p:ph type="sldImg" idx="2"/>
+          </p:nvPr>
+        </p:nvSpPr>
+        <p:spPr/>
+      </p:sp>
+      <p:sp>
+        <p:nvSpPr>
+          <p:cNvPr id="3" name="Notes Placeholder 2"/>
+          <p:cNvSpPr>
+            <a:spLocks noGrp="1"/>
+          </p:cNvSpPr>
+          <p:nvPr>
+            <p:ph type="body" idx="3" sz="quarter"/>
+          </p:nvPr>
+        </p:nvSpPr>
+        <p:spPr/>
+        <p:txBody>
+          <a:bodyPr/>
+          <a:lstStyle/>
+          <a:p>
+            <a:r>
+              <a:t>Open with the one-liner: a computer that hears 35 spoken commands. This is your deep-learning course project — everything here was trained and measured by you, on your own machine.</a:t>
+            </a:r>
+          </a:p>
+        </p:txBody>
+      </p:sp>
+      <p:sp>
+        <p:nvSpPr>
+          <p:cNvPr id="4" name="Slide Number Placeholder 3"/>
+          <p:cNvSpPr>
+            <a:spLocks noGrp="1"/>
+          </p:cNvSpPr>
+          <p:nvPr>
+            <p:ph type="sldNum" idx="5" sz="quarter"/>
+          </p:nvPr>
+        </p:nvSpPr>
+        <p:spPr/>
+      </p:sp>
+    </p:spTree>
+  </p:cSld>
+  <p:clrMapOvr>
+    <a:masterClrMapping/>
+  </p:clrMapOvr>
+</p:notes>
+</file>
+
+<file path=ppt/notesSlides/notesSlide10.xml><?xml version="1.0" encoding="utf-8"?>
+<p:notes xmlns:a="http://schemas.openxmlformats.org/drawingml/2006/main" xmlns:p="http://schemas.openxmlformats.org/presentationml/2006/main" xmlns:r="http://schemas.openxmlformats.org/officeDocument/2006/relationships">
+  <p:cSld>
+    <p:spTree>
+      <p:nvGrpSpPr>
+        <p:cNvPr id="1" name=""/>
+        <p:cNvGrpSpPr/>
+        <p:nvPr/>
+      </p:nvGrpSpPr>
+      <p:grpSpPr>
+        <a:xfrm>
+          <a:off x="0" y="0"/>
+          <a:ext cx="0" cy="0"/>
+          <a:chOff x="0" y="0"/>
+          <a:chExt cx="0" cy="0"/>
+        </a:xfrm>
+      </p:grpSpPr>
+      <p:sp>
+        <p:nvSpPr>
+          <p:cNvPr id="2" name="Slide Image Placeholder 1"/>
+          <p:cNvSpPr>
+            <a:spLocks noGrp="1"/>
+          </p:cNvSpPr>
+          <p:nvPr>
+            <p:ph type="sldImg" idx="2"/>
+          </p:nvPr>
+        </p:nvSpPr>
+        <p:spPr/>
+      </p:sp>
+      <p:sp>
+        <p:nvSpPr>
+          <p:cNvPr id="3" name="Notes Placeholder 2"/>
+          <p:cNvSpPr>
+            <a:spLocks noGrp="1"/>
+          </p:cNvSpPr>
+          <p:nvPr>
+            <p:ph type="body" idx="3" sz="quarter"/>
+          </p:nvPr>
+        </p:nvSpPr>
+        <p:spPr/>
+        <p:txBody>
+          <a:bodyPr/>
+          <a:lstStyle/>
+          <a:p>
+            <a:r>
+              <a:t>Be honest here: accuracy collapses in heavy noise. Graceful degradation, no cliff — and the obvious next step is training on noisy clips. Admitting a weakness with a plan beats hiding it.</a:t>
+            </a:r>
+          </a:p>
+        </p:txBody>
+      </p:sp>
+      <p:sp>
+        <p:nvSpPr>
+          <p:cNvPr id="4" name="Slide Number Placeholder 3"/>
+          <p:cNvSpPr>
+            <a:spLocks noGrp="1"/>
+          </p:cNvSpPr>
+          <p:nvPr>
+            <p:ph type="sldNum" idx="5" sz="quarter"/>
+          </p:nvPr>
+        </p:nvSpPr>
+        <p:spPr/>
+      </p:sp>
+    </p:spTree>
+  </p:cSld>
+  <p:clrMapOvr>
+    <a:masterClrMapping/>
+  </p:clrMapOvr>
+</p:notes>
+</file>
+
+<file path=ppt/notesSlides/notesSlide11.xml><?xml version="1.0" encoding="utf-8"?>
+<p:notes xmlns:a="http://schemas.openxmlformats.org/drawingml/2006/main" xmlns:p="http://schemas.openxmlformats.org/presentationml/2006/main" xmlns:r="http://schemas.openxmlformats.org/officeDocument/2006/relationships">
+  <p:cSld>
+    <p:spTree>
+      <p:nvGrpSpPr>
+        <p:cNvPr id="1" name=""/>
+        <p:cNvGrpSpPr/>
+        <p:nvPr/>
+      </p:nvGrpSpPr>
+      <p:grpSpPr>
+        <a:xfrm>
+          <a:off x="0" y="0"/>
+          <a:ext cx="0" cy="0"/>
+          <a:chOff x="0" y="0"/>
+          <a:chExt cx="0" cy="0"/>
+        </a:xfrm>
+      </p:grpSpPr>
+      <p:sp>
+        <p:nvSpPr>
+          <p:cNvPr id="2" name="Slide Image Placeholder 1"/>
+          <p:cNvSpPr>
+            <a:spLocks noGrp="1"/>
+          </p:cNvSpPr>
+          <p:nvPr>
+            <p:ph type="sldImg" idx="2"/>
+          </p:nvPr>
+        </p:nvSpPr>
+        <p:spPr/>
+      </p:sp>
+      <p:sp>
+        <p:nvSpPr>
+          <p:cNvPr id="3" name="Notes Placeholder 2"/>
+          <p:cNvSpPr>
+            <a:spLocks noGrp="1"/>
+          </p:cNvSpPr>
+          <p:nvPr>
+            <p:ph type="body" idx="3" sz="quarter"/>
+          </p:nvPr>
+        </p:nvSpPr>
+        <p:spPr/>
+        <p:txBody>
+          <a:bodyPr/>
+          <a:lstStyle/>
+          <a:p>
+            <a:r>
+              <a:t>Demo tip: have a backup .wav ready in case the classroom mic misbehaves. Show the top-3 predictions — the model's uncertainty is interesting, not embarrassing.</a:t>
+            </a:r>
+          </a:p>
+        </p:txBody>
+      </p:sp>
+      <p:sp>
+        <p:nvSpPr>
+          <p:cNvPr id="4" name="Slide Number Placeholder 3"/>
+          <p:cNvSpPr>
+            <a:spLocks noGrp="1"/>
+          </p:cNvSpPr>
+          <p:nvPr>
+            <p:ph type="sldNum" idx="5" sz="quarter"/>
+          </p:nvPr>
+        </p:nvSpPr>
+        <p:spPr/>
+      </p:sp>
+    </p:spTree>
+  </p:cSld>
+  <p:clrMapOvr>
+    <a:masterClrMapping/>
+  </p:clrMapOvr>
+</p:notes>
+</file>
+
+<file path=ppt/notesSlides/notesSlide12.xml><?xml version="1.0" encoding="utf-8"?>
+<p:notes xmlns:a="http://schemas.openxmlformats.org/drawingml/2006/main" xmlns:p="http://schemas.openxmlformats.org/presentationml/2006/main" xmlns:r="http://schemas.openxmlformats.org/officeDocument/2006/relationships">
+  <p:cSld>
+    <p:spTree>
+      <p:nvGrpSpPr>
+        <p:cNvPr id="1" name=""/>
+        <p:cNvGrpSpPr/>
+        <p:nvPr/>
+      </p:nvGrpSpPr>
+      <p:grpSpPr>
+        <a:xfrm>
+          <a:off x="0" y="0"/>
+          <a:ext cx="0" cy="0"/>
+          <a:chOff x="0" y="0"/>
+          <a:chExt cx="0" cy="0"/>
+        </a:xfrm>
+      </p:grpSpPr>
+      <p:sp>
+        <p:nvSpPr>
+          <p:cNvPr id="2" name="Slide Image Placeholder 1"/>
+          <p:cNvSpPr>
+            <a:spLocks noGrp="1"/>
+          </p:cNvSpPr>
+          <p:nvPr>
+            <p:ph type="sldImg" idx="2"/>
+          </p:nvPr>
+        </p:nvSpPr>
+        <p:spPr/>
+      </p:sp>
+      <p:sp>
+        <p:nvSpPr>
+          <p:cNvPr id="3" name="Notes Placeholder 2"/>
+          <p:cNvSpPr>
+            <a:spLocks noGrp="1"/>
+          </p:cNvSpPr>
+          <p:nvPr>
+            <p:ph type="body" idx="3" sz="quarter"/>
+          </p:nvPr>
+        </p:nvSpPr>
+        <p:spPr/>
+        <p:txBody>
+          <a:bodyPr/>
+          <a:lstStyle/>
+          <a:p>
+            <a:r>
+              <a:t>The personalization angle is what makes this project yours, not a tutorial copy: your voice, your words. Close with the representation lesson — it's the most quotable line of the talk.</a:t>
+            </a:r>
+          </a:p>
+        </p:txBody>
+      </p:sp>
+      <p:sp>
+        <p:nvSpPr>
+          <p:cNvPr id="4" name="Slide Number Placeholder 3"/>
+          <p:cNvSpPr>
+            <a:spLocks noGrp="1"/>
+          </p:cNvSpPr>
+          <p:nvPr>
+            <p:ph type="sldNum" idx="5" sz="quarter"/>
+          </p:nvPr>
+        </p:nvSpPr>
+        <p:spPr/>
+      </p:sp>
+    </p:spTree>
+  </p:cSld>
+  <p:clrMapOvr>
+    <a:masterClrMapping/>
+  </p:clrMapOvr>
+</p:notes>
+</file>
+
+<file path=ppt/notesSlides/notesSlide13.xml><?xml version="1.0" encoding="utf-8"?>
+<p:notes xmlns:a="http://schemas.openxmlformats.org/drawingml/2006/main" xmlns:p="http://schemas.openxmlformats.org/presentationml/2006/main" xmlns:r="http://schemas.openxmlformats.org/officeDocument/2006/relationships">
+  <p:cSld>
+    <p:spTree>
+      <p:nvGrpSpPr>
+        <p:cNvPr id="1" name=""/>
+        <p:cNvGrpSpPr/>
+        <p:nvPr/>
+      </p:nvGrpSpPr>
+      <p:grpSpPr>
+        <a:xfrm>
+          <a:off x="0" y="0"/>
+          <a:ext cx="0" cy="0"/>
+          <a:chOff x="0" y="0"/>
+          <a:chExt cx="0" cy="0"/>
+        </a:xfrm>
+      </p:grpSpPr>
+      <p:sp>
+        <p:nvSpPr>
+          <p:cNvPr id="2" name="Slide Image Placeholder 1"/>
+          <p:cNvSpPr>
+            <a:spLocks noGrp="1"/>
+          </p:cNvSpPr>
+          <p:nvPr>
+            <p:ph type="sldImg" idx="2"/>
+          </p:nvPr>
+        </p:nvSpPr>
+        <p:spPr/>
+      </p:sp>
+      <p:sp>
+        <p:nvSpPr>
+          <p:cNvPr id="3" name="Notes Placeholder 2"/>
+          <p:cNvSpPr>
+            <a:spLocks noGrp="1"/>
+          </p:cNvSpPr>
+          <p:nvPr>
+            <p:ph type="body" idx="3" sz="quarter"/>
+          </p:nvPr>
+        </p:nvSpPr>
+        <p:spPr/>
+        <p:txBody>
+          <a:bodyPr/>
+          <a:lstStyle/>
+          <a:p>
+            <a:r>
+              <a:t>Thank the audience, point at the repo link, invite questions. If asked about the 63%: it's a clean baseline — augmentation and a bigger model are the known next steps.</a:t>
+            </a:r>
+          </a:p>
+        </p:txBody>
+      </p:sp>
+      <p:sp>
+        <p:nvSpPr>
+          <p:cNvPr id="4" name="Slide Number Placeholder 3"/>
+          <p:cNvSpPr>
+            <a:spLocks noGrp="1"/>
+          </p:cNvSpPr>
+          <p:nvPr>
+            <p:ph type="sldNum" idx="5" sz="quarter"/>
+          </p:nvPr>
+        </p:nvSpPr>
+        <p:spPr/>
+      </p:sp>
+    </p:spTree>
+  </p:cSld>
+  <p:clrMapOvr>
+    <a:masterClrMapping/>
+  </p:clrMapOvr>
+</p:notes>
+</file>
+
+<file path=ppt/notesSlides/notesSlide2.xml><?xml version="1.0" encoding="utf-8"?>
+<p:notes xmlns:a="http://schemas.openxmlformats.org/drawingml/2006/main" xmlns:p="http://schemas.openxmlformats.org/presentationml/2006/main" xmlns:r="http://schemas.openxmlformats.org/officeDocument/2006/relationships">
+  <p:cSld>
+    <p:spTree>
+      <p:nvGrpSpPr>
+        <p:cNvPr id="1" name=""/>
+        <p:cNvGrpSpPr/>
+        <p:nvPr/>
+      </p:nvGrpSpPr>
+      <p:grpSpPr>
+        <a:xfrm>
+          <a:off x="0" y="0"/>
+          <a:ext cx="0" cy="0"/>
+          <a:chOff x="0" y="0"/>
+          <a:chExt cx="0" cy="0"/>
+        </a:xfrm>
+      </p:grpSpPr>
+      <p:sp>
+        <p:nvSpPr>
+          <p:cNvPr id="2" name="Slide Image Placeholder 1"/>
+          <p:cNvSpPr>
+            <a:spLocks noGrp="1"/>
+          </p:cNvSpPr>
+          <p:nvPr>
+            <p:ph type="sldImg" idx="2"/>
+          </p:nvPr>
+        </p:nvSpPr>
+        <p:spPr/>
+      </p:sp>
+      <p:sp>
+        <p:nvSpPr>
+          <p:cNvPr id="3" name="Notes Placeholder 2"/>
+          <p:cNvSpPr>
+            <a:spLocks noGrp="1"/>
+          </p:cNvSpPr>
+          <p:nvPr>
+            <p:ph type="body" idx="3" sz="quarter"/>
+          </p:nvPr>
+        </p:nvSpPr>
+        <p:spPr/>
+        <p:txBody>
+          <a:bodyPr/>
+          <a:lstStyle/>
+          <a:p>
+            <a:r>
+              <a:t>Keyword spotting = always-on listening for a fixed vocabulary. Stress the constraints — tiny, fast, offline — that's what justifies a small CNN instead of a giant model.</a:t>
+            </a:r>
+          </a:p>
+        </p:txBody>
+      </p:sp>
+      <p:sp>
+        <p:nvSpPr>
+          <p:cNvPr id="4" name="Slide Number Placeholder 3"/>
+          <p:cNvSpPr>
+            <a:spLocks noGrp="1"/>
+          </p:cNvSpPr>
+          <p:nvPr>
+            <p:ph type="sldNum" idx="5" sz="quarter"/>
+          </p:nvPr>
+        </p:nvSpPr>
+        <p:spPr/>
+      </p:sp>
+    </p:spTree>
+  </p:cSld>
+  <p:clrMapOvr>
+    <a:masterClrMapping/>
+  </p:clrMapOvr>
+</p:notes>
+</file>
+
+<file path=ppt/notesSlides/notesSlide3.xml><?xml version="1.0" encoding="utf-8"?>
+<p:notes xmlns:a="http://schemas.openxmlformats.org/drawingml/2006/main" xmlns:p="http://schemas.openxmlformats.org/presentationml/2006/main" xmlns:r="http://schemas.openxmlformats.org/officeDocument/2006/relationships">
+  <p:cSld>
+    <p:spTree>
+      <p:nvGrpSpPr>
+        <p:cNvPr id="1" name=""/>
+        <p:cNvGrpSpPr/>
+        <p:nvPr/>
+      </p:nvGrpSpPr>
+      <p:grpSpPr>
+        <a:xfrm>
+          <a:off x="0" y="0"/>
+          <a:ext cx="0" cy="0"/>
+          <a:chOff x="0" y="0"/>
+          <a:chExt cx="0" cy="0"/>
+        </a:xfrm>
+      </p:grpSpPr>
+      <p:sp>
+        <p:nvSpPr>
+          <p:cNvPr id="2" name="Slide Image Placeholder 1"/>
+          <p:cNvSpPr>
+            <a:spLocks noGrp="1"/>
+          </p:cNvSpPr>
+          <p:nvPr>
+            <p:ph type="sldImg" idx="2"/>
+          </p:nvPr>
+        </p:nvSpPr>
+        <p:spPr/>
+      </p:sp>
+      <p:sp>
+        <p:nvSpPr>
+          <p:cNvPr id="3" name="Notes Placeholder 2"/>
+          <p:cNvSpPr>
+            <a:spLocks noGrp="1"/>
+          </p:cNvSpPr>
+          <p:nvPr>
+            <p:ph type="body" idx="3" sz="quarter"/>
+          </p:nvPr>
+        </p:nvSpPr>
+        <p:spPr/>
+        <p:txBody>
+          <a:bodyPr/>
+          <a:lstStyle/>
+          <a:p>
+            <a:r>
+              <a:t>105k clips, official splits — say why official splits matter: your numbers are comparable to published work, not inflated by a lucky random split.</a:t>
+            </a:r>
+          </a:p>
+        </p:txBody>
+      </p:sp>
+      <p:sp>
+        <p:nvSpPr>
+          <p:cNvPr id="4" name="Slide Number Placeholder 3"/>
+          <p:cNvSpPr>
+            <a:spLocks noGrp="1"/>
+          </p:cNvSpPr>
+          <p:nvPr>
+            <p:ph type="sldNum" idx="5" sz="quarter"/>
+          </p:nvPr>
+        </p:nvSpPr>
+        <p:spPr/>
+      </p:sp>
+    </p:spTree>
+  </p:cSld>
+  <p:clrMapOvr>
+    <a:masterClrMapping/>
+  </p:clrMapOvr>
+</p:notes>
+</file>
+
+<file path=ppt/notesSlides/notesSlide4.xml><?xml version="1.0" encoding="utf-8"?>
+<p:notes xmlns:a="http://schemas.openxmlformats.org/drawingml/2006/main" xmlns:p="http://schemas.openxmlformats.org/presentationml/2006/main" xmlns:r="http://schemas.openxmlformats.org/officeDocument/2006/relationships">
+  <p:cSld>
+    <p:spTree>
+      <p:nvGrpSpPr>
+        <p:cNvPr id="1" name=""/>
+        <p:cNvGrpSpPr/>
+        <p:nvPr/>
+      </p:nvGrpSpPr>
+      <p:grpSpPr>
+        <a:xfrm>
+          <a:off x="0" y="0"/>
+          <a:ext cx="0" cy="0"/>
+          <a:chOff x="0" y="0"/>
+          <a:chExt cx="0" cy="0"/>
+        </a:xfrm>
+      </p:grpSpPr>
+      <p:sp>
+        <p:nvSpPr>
+          <p:cNvPr id="2" name="Slide Image Placeholder 1"/>
+          <p:cNvSpPr>
+            <a:spLocks noGrp="1"/>
+          </p:cNvSpPr>
+          <p:nvPr>
+            <p:ph type="sldImg" idx="2"/>
+          </p:nvPr>
+        </p:nvSpPr>
+        <p:spPr/>
+      </p:sp>
+      <p:sp>
+        <p:nvSpPr>
+          <p:cNvPr id="3" name="Notes Placeholder 2"/>
+          <p:cNvSpPr>
+            <a:spLocks noGrp="1"/>
+          </p:cNvSpPr>
+          <p:nvPr>
+            <p:ph type="body" idx="3" sz="quarter"/>
+          </p:nvPr>
+        </p:nvSpPr>
+        <p:spPr/>
+        <p:txBody>
+          <a:bodyPr/>
+          <a:lstStyle/>
+          <a:p>
+            <a:r>
+              <a:t>Walk the pipeline left to right. The key insight: mel warps pitch the way human ears hear. Log-scale plus normalization because nets train far better on zero-mean inputs.</a:t>
+            </a:r>
+          </a:p>
+        </p:txBody>
+      </p:sp>
+      <p:sp>
+        <p:nvSpPr>
+          <p:cNvPr id="4" name="Slide Number Placeholder 3"/>
+          <p:cNvSpPr>
+            <a:spLocks noGrp="1"/>
+          </p:cNvSpPr>
+          <p:nvPr>
+            <p:ph type="sldNum" idx="5" sz="quarter"/>
+          </p:nvPr>
+        </p:nvSpPr>
+        <p:spPr/>
+      </p:sp>
+    </p:spTree>
+  </p:cSld>
+  <p:clrMapOvr>
+    <a:masterClrMapping/>
+  </p:clrMapOvr>
+</p:notes>
+</file>
+
+<file path=ppt/notesSlides/notesSlide5.xml><?xml version="1.0" encoding="utf-8"?>
+<p:notes xmlns:a="http://schemas.openxmlformats.org/drawingml/2006/main" xmlns:p="http://schemas.openxmlformats.org/presentationml/2006/main" xmlns:r="http://schemas.openxmlformats.org/officeDocument/2006/relationships">
+  <p:cSld>
+    <p:spTree>
+      <p:nvGrpSpPr>
+        <p:cNvPr id="1" name=""/>
+        <p:cNvGrpSpPr/>
+        <p:nvPr/>
+      </p:nvGrpSpPr>
+      <p:grpSpPr>
+        <a:xfrm>
+          <a:off x="0" y="0"/>
+          <a:ext cx="0" cy="0"/>
+          <a:chOff x="0" y="0"/>
+          <a:chExt cx="0" cy="0"/>
+        </a:xfrm>
+      </p:grpSpPr>
+      <p:sp>
+        <p:nvSpPr>
+          <p:cNvPr id="2" name="Slide Image Placeholder 1"/>
+          <p:cNvSpPr>
+            <a:spLocks noGrp="1"/>
+          </p:cNvSpPr>
+          <p:nvPr>
+            <p:ph type="sldImg" idx="2"/>
+          </p:nvPr>
+        </p:nvSpPr>
+        <p:spPr/>
+      </p:sp>
+      <p:sp>
+        <p:nvSpPr>
+          <p:cNvPr id="3" name="Notes Placeholder 2"/>
+          <p:cNvSpPr>
+            <a:spLocks noGrp="1"/>
+          </p:cNvSpPr>
+          <p:nvPr>
+            <p:ph type="body" idx="3" sz="quarter"/>
+          </p:nvPr>
+        </p:nvSpPr>
+        <p:spPr/>
+        <p:txBody>
+          <a:bodyPr/>
+          <a:lstStyle/>
+          <a:p>
+            <a:r>
+              <a:t>Walk each block left to right. Point at the coral block — the AdaptiveAvgPool — and tease it: that's the fix from the debugging story coming up next.</a:t>
+            </a:r>
+          </a:p>
+        </p:txBody>
+      </p:sp>
+      <p:sp>
+        <p:nvSpPr>
+          <p:cNvPr id="4" name="Slide Number Placeholder 3"/>
+          <p:cNvSpPr>
+            <a:spLocks noGrp="1"/>
+          </p:cNvSpPr>
+          <p:nvPr>
+            <p:ph type="sldNum" idx="5" sz="quarter"/>
+          </p:nvPr>
+        </p:nvSpPr>
+        <p:spPr/>
+      </p:sp>
+    </p:spTree>
+  </p:cSld>
+  <p:clrMapOvr>
+    <a:masterClrMapping/>
+  </p:clrMapOvr>
+</p:notes>
+</file>
+
+<file path=ppt/notesSlides/notesSlide6.xml><?xml version="1.0" encoding="utf-8"?>
+<p:notes xmlns:a="http://schemas.openxmlformats.org/drawingml/2006/main" xmlns:p="http://schemas.openxmlformats.org/presentationml/2006/main" xmlns:r="http://schemas.openxmlformats.org/officeDocument/2006/relationships">
+  <p:cSld>
+    <p:spTree>
+      <p:nvGrpSpPr>
+        <p:cNvPr id="1" name=""/>
+        <p:cNvGrpSpPr/>
+        <p:nvPr/>
+      </p:nvGrpSpPr>
+      <p:grpSpPr>
+        <a:xfrm>
+          <a:off x="0" y="0"/>
+          <a:ext cx="0" cy="0"/>
+          <a:chOff x="0" y="0"/>
+          <a:chExt cx="0" cy="0"/>
+        </a:xfrm>
+      </p:grpSpPr>
+      <p:sp>
+        <p:nvSpPr>
+          <p:cNvPr id="2" name="Slide Image Placeholder 1"/>
+          <p:cNvSpPr>
+            <a:spLocks noGrp="1"/>
+          </p:cNvSpPr>
+          <p:nvPr>
+            <p:ph type="sldImg" idx="2"/>
+          </p:nvPr>
+        </p:nvSpPr>
+        <p:spPr/>
+      </p:sp>
+      <p:sp>
+        <p:nvSpPr>
+          <p:cNvPr id="3" name="Notes Placeholder 2"/>
+          <p:cNvSpPr>
+            <a:spLocks noGrp="1"/>
+          </p:cNvSpPr>
+          <p:nvPr>
+            <p:ph type="body" idx="3" sz="quarter"/>
+          </p:nvPr>
+        </p:nvSpPr>
+        <p:spPr/>
+        <p:txBody>
+          <a:bodyPr/>
+          <a:lstStyle/>
+          <a:p>
+            <a:r>
+              <a:t>15 epochs on CPU, Adam. Best checkpoint picked by validation accuracy — test set never touched during training, so the test number is honest.</a:t>
+            </a:r>
+          </a:p>
+        </p:txBody>
+      </p:sp>
+      <p:sp>
+        <p:nvSpPr>
+          <p:cNvPr id="4" name="Slide Number Placeholder 3"/>
+          <p:cNvSpPr>
+            <a:spLocks noGrp="1"/>
+          </p:cNvSpPr>
+          <p:nvPr>
+            <p:ph type="sldNum" idx="5" sz="quarter"/>
+          </p:nvPr>
+        </p:nvSpPr>
+        <p:spPr/>
+      </p:sp>
+    </p:spTree>
+  </p:cSld>
+  <p:clrMapOvr>
+    <a:masterClrMapping/>
+  </p:clrMapOvr>
+</p:notes>
+</file>
+
+<file path=ppt/notesSlides/notesSlide7.xml><?xml version="1.0" encoding="utf-8"?>
+<p:notes xmlns:a="http://schemas.openxmlformats.org/drawingml/2006/main" xmlns:p="http://schemas.openxmlformats.org/presentationml/2006/main" xmlns:r="http://schemas.openxmlformats.org/officeDocument/2006/relationships">
+  <p:cSld>
+    <p:spTree>
+      <p:nvGrpSpPr>
+        <p:cNvPr id="1" name=""/>
+        <p:cNvGrpSpPr/>
+        <p:nvPr/>
+      </p:nvGrpSpPr>
+      <p:grpSpPr>
+        <a:xfrm>
+          <a:off x="0" y="0"/>
+          <a:ext cx="0" cy="0"/>
+          <a:chOff x="0" y="0"/>
+          <a:chExt cx="0" cy="0"/>
+        </a:xfrm>
+      </p:grpSpPr>
+      <p:sp>
+        <p:nvSpPr>
+          <p:cNvPr id="2" name="Slide Image Placeholder 1"/>
+          <p:cNvSpPr>
+            <a:spLocks noGrp="1"/>
+          </p:cNvSpPr>
+          <p:nvPr>
+            <p:ph type="sldImg" idx="2"/>
+          </p:nvPr>
+        </p:nvSpPr>
+        <p:spPr/>
+      </p:sp>
+      <p:sp>
+        <p:nvSpPr>
+          <p:cNvPr id="3" name="Notes Placeholder 2"/>
+          <p:cNvSpPr>
+            <a:spLocks noGrp="1"/>
+          </p:cNvSpPr>
+          <p:nvPr>
+            <p:ph type="body" idx="3" sz="quarter"/>
+          </p:nvPr>
+        </p:nvSpPr>
+        <p:spPr/>
+        <p:txBody>
+          <a:bodyPr/>
+          <a:lstStyle/>
+          <a:p>
+            <a:r>
+              <a:t>Tell the debugging story like it happened: 52.7% stall, diagnosed destroyed time resolution, AdaptiveAvgPool fix, +10.6 points. Professors love this slide — it proves you think, not just train.</a:t>
+            </a:r>
+          </a:p>
+        </p:txBody>
+      </p:sp>
+      <p:sp>
+        <p:nvSpPr>
+          <p:cNvPr id="4" name="Slide Number Placeholder 3"/>
+          <p:cNvSpPr>
+            <a:spLocks noGrp="1"/>
+          </p:cNvSpPr>
+          <p:nvPr>
+            <p:ph type="sldNum" idx="5" sz="quarter"/>
+          </p:nvPr>
+        </p:nvSpPr>
+        <p:spPr/>
+      </p:sp>
+    </p:spTree>
+  </p:cSld>
+  <p:clrMapOvr>
+    <a:masterClrMapping/>
+  </p:clrMapOvr>
+</p:notes>
+</file>
+
+<file path=ppt/notesSlides/notesSlide8.xml><?xml version="1.0" encoding="utf-8"?>
+<p:notes xmlns:a="http://schemas.openxmlformats.org/drawingml/2006/main" xmlns:p="http://schemas.openxmlformats.org/presentationml/2006/main" xmlns:r="http://schemas.openxmlformats.org/officeDocument/2006/relationships">
+  <p:cSld>
+    <p:spTree>
+      <p:nvGrpSpPr>
+        <p:cNvPr id="1" name=""/>
+        <p:cNvGrpSpPr/>
+        <p:nvPr/>
+      </p:nvGrpSpPr>
+      <p:grpSpPr>
+        <a:xfrm>
+          <a:off x="0" y="0"/>
+          <a:ext cx="0" cy="0"/>
+          <a:chOff x="0" y="0"/>
+          <a:chExt cx="0" cy="0"/>
+        </a:xfrm>
+      </p:grpSpPr>
+      <p:sp>
+        <p:nvSpPr>
+          <p:cNvPr id="2" name="Slide Image Placeholder 1"/>
+          <p:cNvSpPr>
+            <a:spLocks noGrp="1"/>
+          </p:cNvSpPr>
+          <p:nvPr>
+            <p:ph type="sldImg" idx="2"/>
+          </p:nvPr>
+        </p:nvSpPr>
+        <p:spPr/>
+      </p:sp>
+      <p:sp>
+        <p:nvSpPr>
+          <p:cNvPr id="3" name="Notes Placeholder 2"/>
+          <p:cNvSpPr>
+            <a:spLocks noGrp="1"/>
+          </p:cNvSpPr>
+          <p:nvPr>
+            <p:ph type="body" idx="3" sz="quarter"/>
+          </p:nvPr>
+        </p:nvSpPr>
+        <p:spPr/>
+        <p:txBody>
+          <a:bodyPr/>
+          <a:lstStyle/>
+          <a:p>
+            <a:r>
+              <a:t>Read the three bars top to bottom. The gap between CNN and SVM is the story: this is what deep learning buys on this task. Random guessing at 2.9% shows how far 63% really is.</a:t>
+            </a:r>
+          </a:p>
+        </p:txBody>
+      </p:sp>
+      <p:sp>
+        <p:nvSpPr>
+          <p:cNvPr id="4" name="Slide Number Placeholder 3"/>
+          <p:cNvSpPr>
+            <a:spLocks noGrp="1"/>
+          </p:cNvSpPr>
+          <p:nvPr>
+            <p:ph type="sldNum" idx="5" sz="quarter"/>
+          </p:nvPr>
+        </p:nvSpPr>
+        <p:spPr/>
+      </p:sp>
+    </p:spTree>
+  </p:cSld>
+  <p:clrMapOvr>
+    <a:masterClrMapping/>
+  </p:clrMapOvr>
+</p:notes>
+</file>
+
+<file path=ppt/notesSlides/notesSlide9.xml><?xml version="1.0" encoding="utf-8"?>
+<p:notes xmlns:a="http://schemas.openxmlformats.org/drawingml/2006/main" xmlns:p="http://schemas.openxmlformats.org/presentationml/2006/main" xmlns:r="http://schemas.openxmlformats.org/officeDocument/2006/relationships">
+  <p:cSld>
+    <p:spTree>
+      <p:nvGrpSpPr>
+        <p:cNvPr id="1" name=""/>
+        <p:cNvGrpSpPr/>
+        <p:nvPr/>
+      </p:nvGrpSpPr>
+      <p:grpSpPr>
+        <a:xfrm>
+          <a:off x="0" y="0"/>
+          <a:ext cx="0" cy="0"/>
+          <a:chOff x="0" y="0"/>
+          <a:chExt cx="0" cy="0"/>
+        </a:xfrm>
+      </p:grpSpPr>
+      <p:sp>
+        <p:nvSpPr>
+          <p:cNvPr id="2" name="Slide Image Placeholder 1"/>
+          <p:cNvSpPr>
+            <a:spLocks noGrp="1"/>
+          </p:cNvSpPr>
+          <p:nvPr>
+            <p:ph type="sldImg" idx="2"/>
+          </p:nvPr>
+        </p:nvSpPr>
+        <p:spPr/>
+      </p:sp>
+      <p:sp>
+        <p:nvSpPr>
+          <p:cNvPr id="3" name="Notes Placeholder 2"/>
+          <p:cNvSpPr>
+            <a:spLocks noGrp="1"/>
+          </p:cNvSpPr>
+          <p:nvPr>
+            <p:ph type="body" idx="3" sz="quarter"/>
+          </p:nvPr>
+        </p:nvSpPr>
+        <p:spPr/>
+        <p:txBody>
+          <a:bodyPr/>
+          <a:lstStyle/>
+          <a:p>
+            <a:r>
+              <a:t>Errors are sensible — similar-sounding pairs. Point at go/no and three/tree: even humans mix these up. This is evidence the model learned phonetics, not noise.</a:t>
+            </a:r>
+          </a:p>
+        </p:txBody>
+      </p:sp>
+      <p:sp>
+        <p:nvSpPr>
+          <p:cNvPr id="4" name="Slide Number Placeholder 3"/>
+          <p:cNvSpPr>
+            <a:spLocks noGrp="1"/>
+          </p:cNvSpPr>
+          <p:nvPr>
+            <p:ph type="sldNum" idx="5" sz="quarter"/>
+          </p:nvPr>
+        </p:nvSpPr>
+        <p:spPr/>
+      </p:sp>
+    </p:spTree>
+  </p:cSld>
+  <p:clrMapOvr>
+    <a:masterClrMapping/>
+  </p:clrMapOvr>
+</p:notes>
 </file>
 
 <file path=ppt/slideLayouts/slideLayout1.xml><?xml version="1.0" encoding="utf-8"?>
@@ -3108,15 +4368,39 @@
         <p:nvPr/>
       </p:nvGrpSpPr>
       <p:grpSpPr/>
-      <p:sp>
-        <p:nvSpPr>
-          <p:cNvPr id="2" name="TextBox 1"/>
+      <p:pic>
+        <p:nvPicPr>
+          <p:cNvPr id="2" name="Picture 1" descr="title_strip.png"/>
+          <p:cNvPicPr>
+            <a:picLocks noChangeAspect="1"/>
+          </p:cNvPicPr>
+          <p:nvPr/>
+        </p:nvPicPr>
+        <p:blipFill>
+          <a:blip r:embed="rId2"/>
+          <a:stretch>
+            <a:fillRect/>
+          </a:stretch>
+        </p:blipFill>
+        <p:spPr>
+          <a:xfrm>
+            <a:off x="0" y="5394960"/>
+            <a:ext cx="12191695" cy="1741671"/>
+          </a:xfrm>
+          <a:prstGeom prst="rect">
+            <a:avLst/>
+          </a:prstGeom>
+        </p:spPr>
+      </p:pic>
+      <p:sp>
+        <p:nvSpPr>
+          <p:cNvPr id="3" name="TextBox 2"/>
           <p:cNvSpPr txBox="1"/>
           <p:nvPr/>
         </p:nvSpPr>
         <p:spPr>
           <a:xfrm>
-            <a:off x="914400" y="1463040"/>
+            <a:off x="914400" y="1097280"/>
             <a:ext cx="10332720" cy="1828800"/>
           </a:xfrm>
           <a:prstGeom prst="rect">
@@ -3145,13 +4429,13 @@
       </p:sp>
       <p:sp>
         <p:nvSpPr>
-          <p:cNvPr id="3" name="TextBox 2"/>
+          <p:cNvPr id="4" name="TextBox 3"/>
           <p:cNvSpPr txBox="1"/>
           <p:nvPr/>
         </p:nvSpPr>
         <p:spPr>
           <a:xfrm>
-            <a:off x="914400" y="3108960"/>
+            <a:off x="914400" y="2834640"/>
             <a:ext cx="10332720" cy="914400"/>
           </a:xfrm>
           <a:prstGeom prst="rect">
@@ -3184,13 +4468,13 @@
       </p:sp>
       <p:sp>
         <p:nvSpPr>
-          <p:cNvPr id="4" name="TextBox 3"/>
+          <p:cNvPr id="5" name="TextBox 4"/>
           <p:cNvSpPr txBox="1"/>
           <p:nvPr/>
         </p:nvSpPr>
         <p:spPr>
           <a:xfrm>
-            <a:off x="914400" y="5120640"/>
+            <a:off x="914400" y="4297680"/>
             <a:ext cx="10332720" cy="914400"/>
           </a:xfrm>
           <a:prstGeom prst="rect">
@@ -3217,6 +4501,41 @@
             <a:br/>
             <a:r>
               <a:t>Aditya</a:t>
+            </a:r>
+          </a:p>
+        </p:txBody>
+      </p:sp>
+      <p:sp>
+        <p:nvSpPr>
+          <p:cNvPr id="6" name="TextBox 5"/>
+          <p:cNvSpPr txBox="1"/>
+          <p:nvPr/>
+        </p:nvSpPr>
+        <p:spPr>
+          <a:xfrm>
+            <a:off x="9692640" y="6446520"/>
+            <a:ext cx="2011680" cy="320040"/>
+          </a:xfrm>
+          <a:prstGeom prst="rect">
+            <a:avLst/>
+          </a:prstGeom>
+          <a:noFill/>
+        </p:spPr>
+        <p:txBody>
+          <a:bodyPr wrap="none">
+            <a:spAutoFit/>
+          </a:bodyPr>
+          <a:lstStyle/>
+          <a:p>
+            <a:pPr algn="r">
+              <a:defRPr sz="1100">
+                <a:solidFill>
+                  <a:srgbClr val="BBDDFF"/>
+                </a:solidFill>
+              </a:defRPr>
+            </a:pPr>
+            <a:r>
+              <a:t>voice-command-recognition  •  1/13</a:t>
             </a:r>
           </a:p>
         </p:txBody>
@@ -3292,7 +4611,50 @@
       </p:sp>
       <p:sp>
         <p:nvSpPr>
-          <p:cNvPr id="3" name="TextBox 2"/>
+          <p:cNvPr id="3" name="Rectangle 2"/>
+          <p:cNvSpPr/>
+          <p:nvPr/>
+        </p:nvSpPr>
+        <p:spPr>
+          <a:xfrm>
+            <a:off x="0" y="1051560"/>
+            <a:ext cx="12191695" cy="54864"/>
+          </a:xfrm>
+          <a:prstGeom prst="rect">
+            <a:avLst/>
+          </a:prstGeom>
+          <a:solidFill>
+            <a:srgbClr val="E76F51"/>
+          </a:solidFill>
+          <a:ln>
+            <a:noFill/>
+          </a:ln>
+        </p:spPr>
+        <p:style>
+          <a:lnRef idx="1">
+            <a:schemeClr val="accent1"/>
+          </a:lnRef>
+          <a:fillRef idx="3">
+            <a:schemeClr val="accent1"/>
+          </a:fillRef>
+          <a:effectRef idx="2">
+            <a:schemeClr val="accent1"/>
+          </a:effectRef>
+          <a:fontRef idx="minor">
+            <a:schemeClr val="lt1"/>
+          </a:fontRef>
+        </p:style>
+        <p:txBody>
+          <a:bodyPr rtlCol="0" anchor="ctr"/>
+          <a:lstStyle/>
+          <a:p>
+            <a:pPr algn="ctr"/>
+          </a:p>
+        </p:txBody>
+      </p:sp>
+      <p:sp>
+        <p:nvSpPr>
+          <p:cNvPr id="4" name="TextBox 3"/>
           <p:cNvSpPr txBox="1"/>
           <p:nvPr/>
         </p:nvSpPr>
@@ -3327,13 +4689,13 @@
       </p:sp>
       <p:sp>
         <p:nvSpPr>
-          <p:cNvPr id="4" name="TextBox 3"/>
+          <p:cNvPr id="5" name="TextBox 4"/>
           <p:cNvSpPr txBox="1"/>
           <p:nvPr/>
         </p:nvSpPr>
         <p:spPr>
           <a:xfrm>
-            <a:off x="457200" y="1188720"/>
+            <a:off x="457200" y="1207008"/>
             <a:ext cx="11277295" cy="457200"/>
           </a:xfrm>
           <a:prstGeom prst="rect">
@@ -3362,7 +4724,7 @@
       </p:sp>
       <p:pic>
         <p:nvPicPr>
-          <p:cNvPr id="5" name="Picture 4" descr="noise_robustness.png"/>
+          <p:cNvPr id="6" name="Picture 5" descr="noise_robustness.png"/>
           <p:cNvPicPr>
             <a:picLocks noChangeAspect="1"/>
           </p:cNvPicPr>
@@ -3386,7 +4748,7 @@
       </p:pic>
       <p:sp>
         <p:nvSpPr>
-          <p:cNvPr id="6" name="TextBox 5"/>
+          <p:cNvPr id="7" name="TextBox 6"/>
           <p:cNvSpPr txBox="1"/>
           <p:nvPr/>
         </p:nvSpPr>
@@ -3447,7 +4809,42 @@
               </a:defRPr>
             </a:pPr>
             <a:r>
-              <a:t>Practical takeaway: fine-tuning on noisy clips would be the next step.</a:t>
+              <a:t>Honest weakness — and the natural next step: fine-tuning on noisy clips.</a:t>
+            </a:r>
+          </a:p>
+        </p:txBody>
+      </p:sp>
+      <p:sp>
+        <p:nvSpPr>
+          <p:cNvPr id="8" name="TextBox 7"/>
+          <p:cNvSpPr txBox="1"/>
+          <p:nvPr/>
+        </p:nvSpPr>
+        <p:spPr>
+          <a:xfrm>
+            <a:off x="9692640" y="6446520"/>
+            <a:ext cx="2011680" cy="320040"/>
+          </a:xfrm>
+          <a:prstGeom prst="rect">
+            <a:avLst/>
+          </a:prstGeom>
+          <a:noFill/>
+        </p:spPr>
+        <p:txBody>
+          <a:bodyPr wrap="none">
+            <a:spAutoFit/>
+          </a:bodyPr>
+          <a:lstStyle/>
+          <a:p>
+            <a:pPr algn="r">
+              <a:defRPr sz="1100">
+                <a:solidFill>
+                  <a:srgbClr val="595959"/>
+                </a:solidFill>
+              </a:defRPr>
+            </a:pPr>
+            <a:r>
+              <a:t>voice-command-recognition  •  10/13</a:t>
             </a:r>
           </a:p>
         </p:txBody>
@@ -3523,7 +4920,50 @@
       </p:sp>
       <p:sp>
         <p:nvSpPr>
-          <p:cNvPr id="3" name="TextBox 2"/>
+          <p:cNvPr id="3" name="Rectangle 2"/>
+          <p:cNvSpPr/>
+          <p:nvPr/>
+        </p:nvSpPr>
+        <p:spPr>
+          <a:xfrm>
+            <a:off x="0" y="1051560"/>
+            <a:ext cx="12191695" cy="54864"/>
+          </a:xfrm>
+          <a:prstGeom prst="rect">
+            <a:avLst/>
+          </a:prstGeom>
+          <a:solidFill>
+            <a:srgbClr val="E76F51"/>
+          </a:solidFill>
+          <a:ln>
+            <a:noFill/>
+          </a:ln>
+        </p:spPr>
+        <p:style>
+          <a:lnRef idx="1">
+            <a:schemeClr val="accent1"/>
+          </a:lnRef>
+          <a:fillRef idx="3">
+            <a:schemeClr val="accent1"/>
+          </a:fillRef>
+          <a:effectRef idx="2">
+            <a:schemeClr val="accent1"/>
+          </a:effectRef>
+          <a:fontRef idx="minor">
+            <a:schemeClr val="lt1"/>
+          </a:fontRef>
+        </p:style>
+        <p:txBody>
+          <a:bodyPr rtlCol="0" anchor="ctr"/>
+          <a:lstStyle/>
+          <a:p>
+            <a:pPr algn="ctr"/>
+          </a:p>
+        </p:txBody>
+      </p:sp>
+      <p:sp>
+        <p:nvSpPr>
+          <p:cNvPr id="4" name="TextBox 3"/>
           <p:cNvSpPr txBox="1"/>
           <p:nvPr/>
         </p:nvSpPr>
@@ -3558,13 +4998,13 @@
       </p:sp>
       <p:sp>
         <p:nvSpPr>
-          <p:cNvPr id="4" name="TextBox 3"/>
+          <p:cNvPr id="5" name="TextBox 4"/>
           <p:cNvSpPr txBox="1"/>
           <p:nvPr/>
         </p:nvSpPr>
         <p:spPr>
           <a:xfrm>
-            <a:off x="457200" y="1188720"/>
+            <a:off x="457200" y="1207008"/>
             <a:ext cx="11277295" cy="457200"/>
           </a:xfrm>
           <a:prstGeom prst="rect">
@@ -3593,7 +5033,7 @@
       </p:sp>
       <p:pic>
         <p:nvPicPr>
-          <p:cNvPr id="5" name="Picture 4" descr="waveform_spectrogram_examples.png"/>
+          <p:cNvPr id="6" name="Picture 5" descr="waveform_spectrogram_examples.png"/>
           <p:cNvPicPr>
             <a:picLocks noChangeAspect="1"/>
           </p:cNvPicPr>
@@ -3617,7 +5057,7 @@
       </p:pic>
       <p:sp>
         <p:nvSpPr>
-          <p:cNvPr id="6" name="TextBox 5"/>
+          <p:cNvPr id="7" name="TextBox 6"/>
           <p:cNvSpPr txBox="1"/>
           <p:nvPr/>
         </p:nvSpPr>
@@ -3679,6 +5119,41 @@
             </a:pPr>
             <a:r>
               <a:t>A “custom model” toggle loads your fine-tuned weights after you record your own voice.</a:t>
+            </a:r>
+          </a:p>
+        </p:txBody>
+      </p:sp>
+      <p:sp>
+        <p:nvSpPr>
+          <p:cNvPr id="8" name="TextBox 7"/>
+          <p:cNvSpPr txBox="1"/>
+          <p:nvPr/>
+        </p:nvSpPr>
+        <p:spPr>
+          <a:xfrm>
+            <a:off x="9692640" y="6446520"/>
+            <a:ext cx="2011680" cy="320040"/>
+          </a:xfrm>
+          <a:prstGeom prst="rect">
+            <a:avLst/>
+          </a:prstGeom>
+          <a:noFill/>
+        </p:spPr>
+        <p:txBody>
+          <a:bodyPr wrap="none">
+            <a:spAutoFit/>
+          </a:bodyPr>
+          <a:lstStyle/>
+          <a:p>
+            <a:pPr algn="r">
+              <a:defRPr sz="1100">
+                <a:solidFill>
+                  <a:srgbClr val="595959"/>
+                </a:solidFill>
+              </a:defRPr>
+            </a:pPr>
+            <a:r>
+              <a:t>voice-command-recognition  •  11/13</a:t>
             </a:r>
           </a:p>
         </p:txBody>
@@ -3754,7 +5229,50 @@
       </p:sp>
       <p:sp>
         <p:nvSpPr>
-          <p:cNvPr id="3" name="TextBox 2"/>
+          <p:cNvPr id="3" name="Rectangle 2"/>
+          <p:cNvSpPr/>
+          <p:nvPr/>
+        </p:nvSpPr>
+        <p:spPr>
+          <a:xfrm>
+            <a:off x="0" y="1051560"/>
+            <a:ext cx="12191695" cy="54864"/>
+          </a:xfrm>
+          <a:prstGeom prst="rect">
+            <a:avLst/>
+          </a:prstGeom>
+          <a:solidFill>
+            <a:srgbClr val="E76F51"/>
+          </a:solidFill>
+          <a:ln>
+            <a:noFill/>
+          </a:ln>
+        </p:spPr>
+        <p:style>
+          <a:lnRef idx="1">
+            <a:schemeClr val="accent1"/>
+          </a:lnRef>
+          <a:fillRef idx="3">
+            <a:schemeClr val="accent1"/>
+          </a:fillRef>
+          <a:effectRef idx="2">
+            <a:schemeClr val="accent1"/>
+          </a:effectRef>
+          <a:fontRef idx="minor">
+            <a:schemeClr val="lt1"/>
+          </a:fontRef>
+        </p:style>
+        <p:txBody>
+          <a:bodyPr rtlCol="0" anchor="ctr"/>
+          <a:lstStyle/>
+          <a:p>
+            <a:pPr algn="ctr"/>
+          </a:p>
+        </p:txBody>
+      </p:sp>
+      <p:sp>
+        <p:nvSpPr>
+          <p:cNvPr id="4" name="TextBox 3"/>
           <p:cNvSpPr txBox="1"/>
           <p:nvPr/>
         </p:nvSpPr>
@@ -3789,7 +5307,7 @@
       </p:sp>
       <p:sp>
         <p:nvSpPr>
-          <p:cNvPr id="4" name="TextBox 3"/>
+          <p:cNvPr id="5" name="TextBox 4"/>
           <p:cNvSpPr txBox="1"/>
           <p:nvPr/>
         </p:nvSpPr>
@@ -3851,6 +5369,41 @@
             </a:pPr>
             <a:r>
               <a:t>Key lesson: representation matters more than model size — a good spectrogram + a 1.1M-param CNN beats a bigger model on raw audio.</a:t>
+            </a:r>
+          </a:p>
+        </p:txBody>
+      </p:sp>
+      <p:sp>
+        <p:nvSpPr>
+          <p:cNvPr id="6" name="TextBox 5"/>
+          <p:cNvSpPr txBox="1"/>
+          <p:nvPr/>
+        </p:nvSpPr>
+        <p:spPr>
+          <a:xfrm>
+            <a:off x="9692640" y="6446520"/>
+            <a:ext cx="2011680" cy="320040"/>
+          </a:xfrm>
+          <a:prstGeom prst="rect">
+            <a:avLst/>
+          </a:prstGeom>
+          <a:noFill/>
+        </p:spPr>
+        <p:txBody>
+          <a:bodyPr wrap="none">
+            <a:spAutoFit/>
+          </a:bodyPr>
+          <a:lstStyle/>
+          <a:p>
+            <a:pPr algn="r">
+              <a:defRPr sz="1100">
+                <a:solidFill>
+                  <a:srgbClr val="595959"/>
+                </a:solidFill>
+              </a:defRPr>
+            </a:pPr>
+            <a:r>
+              <a:t>voice-command-recognition  •  12/13</a:t>
             </a:r>
           </a:p>
         </p:txBody>
@@ -3986,6 +5539,41 @@
           </a:p>
         </p:txBody>
       </p:sp>
+      <p:sp>
+        <p:nvSpPr>
+          <p:cNvPr id="5" name="TextBox 4"/>
+          <p:cNvSpPr txBox="1"/>
+          <p:nvPr/>
+        </p:nvSpPr>
+        <p:spPr>
+          <a:xfrm>
+            <a:off x="9692640" y="6446520"/>
+            <a:ext cx="2011680" cy="320040"/>
+          </a:xfrm>
+          <a:prstGeom prst="rect">
+            <a:avLst/>
+          </a:prstGeom>
+          <a:noFill/>
+        </p:spPr>
+        <p:txBody>
+          <a:bodyPr wrap="none">
+            <a:spAutoFit/>
+          </a:bodyPr>
+          <a:lstStyle/>
+          <a:p>
+            <a:pPr algn="r">
+              <a:defRPr sz="1100">
+                <a:solidFill>
+                  <a:srgbClr val="BBDDFF"/>
+                </a:solidFill>
+              </a:defRPr>
+            </a:pPr>
+            <a:r>
+              <a:t>voice-command-recognition  •  13/13</a:t>
+            </a:r>
+          </a:p>
+        </p:txBody>
+      </p:sp>
     </p:spTree>
   </p:cSld>
   <p:clrMapOvr>
@@ -4057,7 +5645,50 @@
       </p:sp>
       <p:sp>
         <p:nvSpPr>
-          <p:cNvPr id="3" name="TextBox 2"/>
+          <p:cNvPr id="3" name="Rectangle 2"/>
+          <p:cNvSpPr/>
+          <p:nvPr/>
+        </p:nvSpPr>
+        <p:spPr>
+          <a:xfrm>
+            <a:off x="0" y="1051560"/>
+            <a:ext cx="12191695" cy="54864"/>
+          </a:xfrm>
+          <a:prstGeom prst="rect">
+            <a:avLst/>
+          </a:prstGeom>
+          <a:solidFill>
+            <a:srgbClr val="E76F51"/>
+          </a:solidFill>
+          <a:ln>
+            <a:noFill/>
+          </a:ln>
+        </p:spPr>
+        <p:style>
+          <a:lnRef idx="1">
+            <a:schemeClr val="accent1"/>
+          </a:lnRef>
+          <a:fillRef idx="3">
+            <a:schemeClr val="accent1"/>
+          </a:fillRef>
+          <a:effectRef idx="2">
+            <a:schemeClr val="accent1"/>
+          </a:effectRef>
+          <a:fontRef idx="minor">
+            <a:schemeClr val="lt1"/>
+          </a:fontRef>
+        </p:style>
+        <p:txBody>
+          <a:bodyPr rtlCol="0" anchor="ctr"/>
+          <a:lstStyle/>
+          <a:p>
+            <a:pPr algn="ctr"/>
+          </a:p>
+        </p:txBody>
+      </p:sp>
+      <p:sp>
+        <p:nvSpPr>
+          <p:cNvPr id="4" name="TextBox 3"/>
           <p:cNvSpPr txBox="1"/>
           <p:nvPr/>
         </p:nvSpPr>
@@ -4092,13 +5723,13 @@
       </p:sp>
       <p:sp>
         <p:nvSpPr>
-          <p:cNvPr id="4" name="TextBox 3"/>
+          <p:cNvPr id="5" name="TextBox 4"/>
           <p:cNvSpPr txBox="1"/>
           <p:nvPr/>
         </p:nvSpPr>
         <p:spPr>
           <a:xfrm>
-            <a:off x="457200" y="1188720"/>
+            <a:off x="457200" y="1207008"/>
             <a:ext cx="11277295" cy="457200"/>
           </a:xfrm>
           <a:prstGeom prst="rect">
@@ -4127,7 +5758,7 @@
       </p:sp>
       <p:sp>
         <p:nvSpPr>
-          <p:cNvPr id="5" name="TextBox 4"/>
+          <p:cNvPr id="6" name="TextBox 5"/>
           <p:cNvSpPr txBox="1"/>
           <p:nvPr/>
         </p:nvSpPr>
@@ -4204,6 +5835,41 @@
             </a:pPr>
             <a:r>
               <a:t>This is a classification problem — but the input is sound, not an image.</a:t>
+            </a:r>
+          </a:p>
+        </p:txBody>
+      </p:sp>
+      <p:sp>
+        <p:nvSpPr>
+          <p:cNvPr id="7" name="TextBox 6"/>
+          <p:cNvSpPr txBox="1"/>
+          <p:nvPr/>
+        </p:nvSpPr>
+        <p:spPr>
+          <a:xfrm>
+            <a:off x="9692640" y="6446520"/>
+            <a:ext cx="2011680" cy="320040"/>
+          </a:xfrm>
+          <a:prstGeom prst="rect">
+            <a:avLst/>
+          </a:prstGeom>
+          <a:noFill/>
+        </p:spPr>
+        <p:txBody>
+          <a:bodyPr wrap="none">
+            <a:spAutoFit/>
+          </a:bodyPr>
+          <a:lstStyle/>
+          <a:p>
+            <a:pPr algn="r">
+              <a:defRPr sz="1100">
+                <a:solidFill>
+                  <a:srgbClr val="595959"/>
+                </a:solidFill>
+              </a:defRPr>
+            </a:pPr>
+            <a:r>
+              <a:t>voice-command-recognition  •  2/13</a:t>
             </a:r>
           </a:p>
         </p:txBody>
@@ -4279,7 +5945,50 @@
       </p:sp>
       <p:sp>
         <p:nvSpPr>
-          <p:cNvPr id="3" name="TextBox 2"/>
+          <p:cNvPr id="3" name="Rectangle 2"/>
+          <p:cNvSpPr/>
+          <p:nvPr/>
+        </p:nvSpPr>
+        <p:spPr>
+          <a:xfrm>
+            <a:off x="0" y="1051560"/>
+            <a:ext cx="12191695" cy="54864"/>
+          </a:xfrm>
+          <a:prstGeom prst="rect">
+            <a:avLst/>
+          </a:prstGeom>
+          <a:solidFill>
+            <a:srgbClr val="E76F51"/>
+          </a:solidFill>
+          <a:ln>
+            <a:noFill/>
+          </a:ln>
+        </p:spPr>
+        <p:style>
+          <a:lnRef idx="1">
+            <a:schemeClr val="accent1"/>
+          </a:lnRef>
+          <a:fillRef idx="3">
+            <a:schemeClr val="accent1"/>
+          </a:fillRef>
+          <a:effectRef idx="2">
+            <a:schemeClr val="accent1"/>
+          </a:effectRef>
+          <a:fontRef idx="minor">
+            <a:schemeClr val="lt1"/>
+          </a:fontRef>
+        </p:style>
+        <p:txBody>
+          <a:bodyPr rtlCol="0" anchor="ctr"/>
+          <a:lstStyle/>
+          <a:p>
+            <a:pPr algn="ctr"/>
+          </a:p>
+        </p:txBody>
+      </p:sp>
+      <p:sp>
+        <p:nvSpPr>
+          <p:cNvPr id="4" name="TextBox 3"/>
           <p:cNvSpPr txBox="1"/>
           <p:nvPr/>
         </p:nvSpPr>
@@ -4314,7 +6023,7 @@
       </p:sp>
       <p:sp>
         <p:nvSpPr>
-          <p:cNvPr id="4" name="TextBox 3"/>
+          <p:cNvPr id="5" name="TextBox 4"/>
           <p:cNvSpPr txBox="1"/>
           <p:nvPr/>
         </p:nvSpPr>
@@ -4397,7 +6106,7 @@
       </p:sp>
       <p:pic>
         <p:nvPicPr>
-          <p:cNvPr id="5" name="Picture 4" descr="class_balance.png"/>
+          <p:cNvPr id="6" name="Picture 5" descr="class_balance.png"/>
           <p:cNvPicPr>
             <a:picLocks noChangeAspect="1"/>
           </p:cNvPicPr>
@@ -4419,6 +6128,41 @@
           </a:prstGeom>
         </p:spPr>
       </p:pic>
+      <p:sp>
+        <p:nvSpPr>
+          <p:cNvPr id="7" name="TextBox 6"/>
+          <p:cNvSpPr txBox="1"/>
+          <p:nvPr/>
+        </p:nvSpPr>
+        <p:spPr>
+          <a:xfrm>
+            <a:off x="9692640" y="6446520"/>
+            <a:ext cx="2011680" cy="320040"/>
+          </a:xfrm>
+          <a:prstGeom prst="rect">
+            <a:avLst/>
+          </a:prstGeom>
+          <a:noFill/>
+        </p:spPr>
+        <p:txBody>
+          <a:bodyPr wrap="none">
+            <a:spAutoFit/>
+          </a:bodyPr>
+          <a:lstStyle/>
+          <a:p>
+            <a:pPr algn="r">
+              <a:defRPr sz="1100">
+                <a:solidFill>
+                  <a:srgbClr val="595959"/>
+                </a:solidFill>
+              </a:defRPr>
+            </a:pPr>
+            <a:r>
+              <a:t>voice-command-recognition  •  3/13</a:t>
+            </a:r>
+          </a:p>
+        </p:txBody>
+      </p:sp>
     </p:spTree>
   </p:cSld>
   <p:clrMapOvr>
@@ -4490,7 +6234,50 @@
       </p:sp>
       <p:sp>
         <p:nvSpPr>
-          <p:cNvPr id="3" name="TextBox 2"/>
+          <p:cNvPr id="3" name="Rectangle 2"/>
+          <p:cNvSpPr/>
+          <p:nvPr/>
+        </p:nvSpPr>
+        <p:spPr>
+          <a:xfrm>
+            <a:off x="0" y="1051560"/>
+            <a:ext cx="12191695" cy="54864"/>
+          </a:xfrm>
+          <a:prstGeom prst="rect">
+            <a:avLst/>
+          </a:prstGeom>
+          <a:solidFill>
+            <a:srgbClr val="E76F51"/>
+          </a:solidFill>
+          <a:ln>
+            <a:noFill/>
+          </a:ln>
+        </p:spPr>
+        <p:style>
+          <a:lnRef idx="1">
+            <a:schemeClr val="accent1"/>
+          </a:lnRef>
+          <a:fillRef idx="3">
+            <a:schemeClr val="accent1"/>
+          </a:fillRef>
+          <a:effectRef idx="2">
+            <a:schemeClr val="accent1"/>
+          </a:effectRef>
+          <a:fontRef idx="minor">
+            <a:schemeClr val="lt1"/>
+          </a:fontRef>
+        </p:style>
+        <p:txBody>
+          <a:bodyPr rtlCol="0" anchor="ctr"/>
+          <a:lstStyle/>
+          <a:p>
+            <a:pPr algn="ctr"/>
+          </a:p>
+        </p:txBody>
+      </p:sp>
+      <p:sp>
+        <p:nvSpPr>
+          <p:cNvPr id="4" name="TextBox 3"/>
           <p:cNvSpPr txBox="1"/>
           <p:nvPr/>
         </p:nvSpPr>
@@ -4525,13 +6312,13 @@
       </p:sp>
       <p:sp>
         <p:nvSpPr>
-          <p:cNvPr id="4" name="TextBox 3"/>
+          <p:cNvPr id="5" name="TextBox 4"/>
           <p:cNvSpPr txBox="1"/>
           <p:nvPr/>
         </p:nvSpPr>
         <p:spPr>
           <a:xfrm>
-            <a:off x="457200" y="1188720"/>
+            <a:off x="457200" y="1207008"/>
             <a:ext cx="11277295" cy="457200"/>
           </a:xfrm>
           <a:prstGeom prst="rect">
@@ -4560,7 +6347,7 @@
       </p:sp>
       <p:sp>
         <p:nvSpPr>
-          <p:cNvPr id="5" name="Rectangle 4"/>
+          <p:cNvPr id="6" name="Rectangle 5"/>
           <p:cNvSpPr/>
           <p:nvPr/>
         </p:nvSpPr>
@@ -4632,7 +6419,7 @@
       </p:sp>
       <p:sp>
         <p:nvSpPr>
-          <p:cNvPr id="6" name="TextBox 5"/>
+          <p:cNvPr id="7" name="TextBox 6"/>
           <p:cNvSpPr txBox="1"/>
           <p:nvPr/>
         </p:nvSpPr>
@@ -4655,7 +6442,7 @@
             <a:pPr>
               <a:defRPr sz="2800">
                 <a:solidFill>
-                  <a:srgbClr val="1F3A5F"/>
+                  <a:srgbClr val="E76F51"/>
                 </a:solidFill>
               </a:defRPr>
             </a:pPr>
@@ -4667,7 +6454,7 @@
       </p:sp>
       <p:sp>
         <p:nvSpPr>
-          <p:cNvPr id="7" name="Rectangle 6"/>
+          <p:cNvPr id="8" name="Rectangle 7"/>
           <p:cNvSpPr/>
           <p:nvPr/>
         </p:nvSpPr>
@@ -4743,7 +6530,7 @@
       </p:sp>
       <p:sp>
         <p:nvSpPr>
-          <p:cNvPr id="8" name="TextBox 7"/>
+          <p:cNvPr id="9" name="TextBox 8"/>
           <p:cNvSpPr txBox="1"/>
           <p:nvPr/>
         </p:nvSpPr>
@@ -4766,7 +6553,7 @@
             <a:pPr>
               <a:defRPr sz="2800">
                 <a:solidFill>
-                  <a:srgbClr val="1F3A5F"/>
+                  <a:srgbClr val="E76F51"/>
                 </a:solidFill>
               </a:defRPr>
             </a:pPr>
@@ -4778,7 +6565,7 @@
       </p:sp>
       <p:sp>
         <p:nvSpPr>
-          <p:cNvPr id="9" name="Rectangle 8"/>
+          <p:cNvPr id="10" name="Rectangle 9"/>
           <p:cNvSpPr/>
           <p:nvPr/>
         </p:nvSpPr>
@@ -4850,7 +6637,7 @@
       </p:sp>
       <p:sp>
         <p:nvSpPr>
-          <p:cNvPr id="10" name="TextBox 9"/>
+          <p:cNvPr id="11" name="TextBox 10"/>
           <p:cNvSpPr txBox="1"/>
           <p:nvPr/>
         </p:nvSpPr>
@@ -4873,7 +6660,7 @@
             <a:pPr>
               <a:defRPr sz="2800">
                 <a:solidFill>
-                  <a:srgbClr val="1F3A5F"/>
+                  <a:srgbClr val="E76F51"/>
                 </a:solidFill>
               </a:defRPr>
             </a:pPr>
@@ -4885,7 +6672,7 @@
       </p:sp>
       <p:sp>
         <p:nvSpPr>
-          <p:cNvPr id="11" name="Rectangle 10"/>
+          <p:cNvPr id="12" name="Rectangle 11"/>
           <p:cNvSpPr/>
           <p:nvPr/>
         </p:nvSpPr>
@@ -4957,7 +6744,7 @@
       </p:sp>
       <p:sp>
         <p:nvSpPr>
-          <p:cNvPr id="12" name="TextBox 11"/>
+          <p:cNvPr id="13" name="TextBox 12"/>
           <p:cNvSpPr txBox="1"/>
           <p:nvPr/>
         </p:nvSpPr>
@@ -5004,6 +6791,41 @@
             </a:pPr>
             <a:r>
               <a:t>Why log + normalize? Loudness is logarithmic, and neural nets train far better on zero-mean inputs.</a:t>
+            </a:r>
+          </a:p>
+        </p:txBody>
+      </p:sp>
+      <p:sp>
+        <p:nvSpPr>
+          <p:cNvPr id="14" name="TextBox 13"/>
+          <p:cNvSpPr txBox="1"/>
+          <p:nvPr/>
+        </p:nvSpPr>
+        <p:spPr>
+          <a:xfrm>
+            <a:off x="9692640" y="6446520"/>
+            <a:ext cx="2011680" cy="320040"/>
+          </a:xfrm>
+          <a:prstGeom prst="rect">
+            <a:avLst/>
+          </a:prstGeom>
+          <a:noFill/>
+        </p:spPr>
+        <p:txBody>
+          <a:bodyPr wrap="none">
+            <a:spAutoFit/>
+          </a:bodyPr>
+          <a:lstStyle/>
+          <a:p>
+            <a:pPr algn="r">
+              <a:defRPr sz="1100">
+                <a:solidFill>
+                  <a:srgbClr val="595959"/>
+                </a:solidFill>
+              </a:defRPr>
+            </a:pPr>
+            <a:r>
+              <a:t>voice-command-recognition  •  4/13</a:t>
             </a:r>
           </a:p>
         </p:txBody>
@@ -5079,7 +6901,50 @@
       </p:sp>
       <p:sp>
         <p:nvSpPr>
-          <p:cNvPr id="3" name="TextBox 2"/>
+          <p:cNvPr id="3" name="Rectangle 2"/>
+          <p:cNvSpPr/>
+          <p:nvPr/>
+        </p:nvSpPr>
+        <p:spPr>
+          <a:xfrm>
+            <a:off x="0" y="1051560"/>
+            <a:ext cx="12191695" cy="54864"/>
+          </a:xfrm>
+          <a:prstGeom prst="rect">
+            <a:avLst/>
+          </a:prstGeom>
+          <a:solidFill>
+            <a:srgbClr val="E76F51"/>
+          </a:solidFill>
+          <a:ln>
+            <a:noFill/>
+          </a:ln>
+        </p:spPr>
+        <p:style>
+          <a:lnRef idx="1">
+            <a:schemeClr val="accent1"/>
+          </a:lnRef>
+          <a:fillRef idx="3">
+            <a:schemeClr val="accent1"/>
+          </a:fillRef>
+          <a:effectRef idx="2">
+            <a:schemeClr val="accent1"/>
+          </a:effectRef>
+          <a:fontRef idx="minor">
+            <a:schemeClr val="lt1"/>
+          </a:fontRef>
+        </p:style>
+        <p:txBody>
+          <a:bodyPr rtlCol="0" anchor="ctr"/>
+          <a:lstStyle/>
+          <a:p>
+            <a:pPr algn="ctr"/>
+          </a:p>
+        </p:txBody>
+      </p:sp>
+      <p:sp>
+        <p:nvSpPr>
+          <p:cNvPr id="4" name="TextBox 3"/>
           <p:cNvSpPr txBox="1"/>
           <p:nvPr/>
         </p:nvSpPr>
@@ -5114,13 +6979,13 @@
       </p:sp>
       <p:sp>
         <p:nvSpPr>
-          <p:cNvPr id="4" name="TextBox 3"/>
+          <p:cNvPr id="5" name="TextBox 4"/>
           <p:cNvSpPr txBox="1"/>
           <p:nvPr/>
         </p:nvSpPr>
         <p:spPr>
           <a:xfrm>
-            <a:off x="457200" y="1188720"/>
+            <a:off x="457200" y="1207008"/>
             <a:ext cx="11277295" cy="457200"/>
           </a:xfrm>
           <a:prstGeom prst="rect">
@@ -5149,14 +7014,86 @@
       </p:sp>
       <p:sp>
         <p:nvSpPr>
-          <p:cNvPr id="5" name="TextBox 4"/>
+          <p:cNvPr id="6" name="Rectangle 5"/>
+          <p:cNvSpPr/>
+          <p:nvPr/>
+        </p:nvSpPr>
+        <p:spPr>
+          <a:xfrm>
+            <a:off x="502920" y="2194560"/>
+            <a:ext cx="1965960" cy="2194560"/>
+          </a:xfrm>
+          <a:prstGeom prst="rect">
+            <a:avLst/>
+          </a:prstGeom>
+          <a:solidFill>
+            <a:srgbClr val="1F3A5F"/>
+          </a:solidFill>
+          <a:ln>
+            <a:noFill/>
+          </a:ln>
+        </p:spPr>
+        <p:style>
+          <a:lnRef idx="1">
+            <a:schemeClr val="accent1"/>
+          </a:lnRef>
+          <a:fillRef idx="3">
+            <a:schemeClr val="accent1"/>
+          </a:fillRef>
+          <a:effectRef idx="2">
+            <a:schemeClr val="accent1"/>
+          </a:effectRef>
+          <a:fontRef idx="minor">
+            <a:schemeClr val="lt1"/>
+          </a:fontRef>
+        </p:style>
+        <p:txBody>
+          <a:bodyPr rtlCol="0" anchor="ctr" wrap="square"/>
+          <a:lstStyle/>
+          <a:p>
+            <a:pPr algn="ctr">
+              <a:defRPr sz="1900" b="1">
+                <a:solidFill>
+                  <a:srgbClr val="FFFFFF"/>
+                </a:solidFill>
+              </a:defRPr>
+            </a:pPr>
+            <a:r>
+              <a:t>INPUT</a:t>
+            </a:r>
+          </a:p>
+          <a:p>
+            <a:pPr algn="ctr">
+              <a:defRPr sz="1400">
+                <a:solidFill>
+                  <a:srgbClr val="FFFFFF"/>
+                </a:solidFill>
+              </a:defRPr>
+            </a:pPr>
+            <a:r>
+              <a:t>1 × 40 × 101</a:t>
+            </a:r>
+            <a:br/>
+            <a:r>
+              <a:t>log-mel</a:t>
+            </a:r>
+            <a:br/>
+            <a:r>
+              <a:t>spectrogram</a:t>
+            </a:r>
+          </a:p>
+        </p:txBody>
+      </p:sp>
+      <p:sp>
+        <p:nvSpPr>
+          <p:cNvPr id="7" name="TextBox 6"/>
           <p:cNvSpPr txBox="1"/>
           <p:nvPr/>
         </p:nvSpPr>
         <p:spPr>
           <a:xfrm>
-            <a:off x="640080" y="2103120"/>
-            <a:ext cx="10881360" cy="2743200"/>
+            <a:off x="2468880" y="3063240"/>
+            <a:ext cx="292608" cy="457200"/>
           </a:xfrm>
           <a:prstGeom prst="rect">
             <a:avLst/>
@@ -5164,102 +7101,427 @@
           <a:noFill/>
         </p:spPr>
         <p:txBody>
-          <a:bodyPr wrap="square">
+          <a:bodyPr wrap="none">
             <a:spAutoFit/>
           </a:bodyPr>
           <a:lstStyle/>
           <a:p>
             <a:pPr>
-              <a:spcAft>
-                <a:spcPts val="1400"/>
-              </a:spcAft>
-              <a:defRPr sz="2200">
-                <a:solidFill>
-                  <a:srgbClr val="595959"/>
-                </a:solidFill>
-                <a:latin typeface="Consolas"/>
-              </a:defRPr>
-            </a:pPr>
-            <a:r>
-              <a:t>Input  (1 × 40 × 101)  log-mel spectrogram</a:t>
-            </a:r>
-          </a:p>
+              <a:defRPr sz="2600">
+                <a:solidFill>
+                  <a:srgbClr val="E76F51"/>
+                </a:solidFill>
+              </a:defRPr>
+            </a:pPr>
+            <a:r>
+              <a:t>▶</a:t>
+            </a:r>
+          </a:p>
+        </p:txBody>
+      </p:sp>
+      <p:sp>
+        <p:nvSpPr>
+          <p:cNvPr id="8" name="Rectangle 7"/>
+          <p:cNvSpPr/>
+          <p:nvPr/>
+        </p:nvSpPr>
+        <p:spPr>
+          <a:xfrm>
+            <a:off x="2761488" y="2194560"/>
+            <a:ext cx="1965960" cy="2194560"/>
+          </a:xfrm>
+          <a:prstGeom prst="rect">
+            <a:avLst/>
+          </a:prstGeom>
+          <a:solidFill>
+            <a:srgbClr val="1F3A5F"/>
+          </a:solidFill>
+          <a:ln>
+            <a:noFill/>
+          </a:ln>
+        </p:spPr>
+        <p:style>
+          <a:lnRef idx="1">
+            <a:schemeClr val="accent1"/>
+          </a:lnRef>
+          <a:fillRef idx="3">
+            <a:schemeClr val="accent1"/>
+          </a:fillRef>
+          <a:effectRef idx="2">
+            <a:schemeClr val="accent1"/>
+          </a:effectRef>
+          <a:fontRef idx="minor">
+            <a:schemeClr val="lt1"/>
+          </a:fontRef>
+        </p:style>
+        <p:txBody>
+          <a:bodyPr rtlCol="0" anchor="ctr" wrap="square"/>
+          <a:lstStyle/>
+          <a:p>
+            <a:pPr algn="ctr">
+              <a:defRPr sz="1900" b="1">
+                <a:solidFill>
+                  <a:srgbClr val="FFFFFF"/>
+                </a:solidFill>
+              </a:defRPr>
+            </a:pPr>
+            <a:r>
+              <a:t>CONV ×2</a:t>
+            </a:r>
+          </a:p>
+          <a:p>
+            <a:pPr algn="ctr">
+              <a:defRPr sz="1400">
+                <a:solidFill>
+                  <a:srgbClr val="FFFFFF"/>
+                </a:solidFill>
+              </a:defRPr>
+            </a:pPr>
+            <a:r>
+              <a:t>64 → 128 ch</a:t>
+            </a:r>
+            <a:br/>
+            <a:r>
+              <a:t>3×3 + BN + ReLU</a:t>
+            </a:r>
+            <a:br/>
+            <a:r>
+              <a:t>MaxPool + Dropout</a:t>
+            </a:r>
+          </a:p>
+        </p:txBody>
+      </p:sp>
+      <p:sp>
+        <p:nvSpPr>
+          <p:cNvPr id="9" name="TextBox 8"/>
+          <p:cNvSpPr txBox="1"/>
+          <p:nvPr/>
+        </p:nvSpPr>
+        <p:spPr>
+          <a:xfrm>
+            <a:off x="4727448" y="3063240"/>
+            <a:ext cx="292608" cy="457200"/>
+          </a:xfrm>
+          <a:prstGeom prst="rect">
+            <a:avLst/>
+          </a:prstGeom>
+          <a:noFill/>
+        </p:spPr>
+        <p:txBody>
+          <a:bodyPr wrap="none">
+            <a:spAutoFit/>
+          </a:bodyPr>
+          <a:lstStyle/>
           <a:p>
             <a:pPr>
-              <a:spcAft>
-                <a:spcPts val="1400"/>
-              </a:spcAft>
-              <a:defRPr sz="2200">
-                <a:solidFill>
-                  <a:srgbClr val="595959"/>
-                </a:solidFill>
-                <a:latin typeface="Consolas"/>
-              </a:defRPr>
-            </a:pPr>
-            <a:r>
-              <a:t>Conv 1→64 (3×3) → BatchNorm → ReLU → MaxPool(2×2) → Dropout(0.25)</a:t>
-            </a:r>
-          </a:p>
+              <a:defRPr sz="2600">
+                <a:solidFill>
+                  <a:srgbClr val="E76F51"/>
+                </a:solidFill>
+              </a:defRPr>
+            </a:pPr>
+            <a:r>
+              <a:t>▶</a:t>
+            </a:r>
+          </a:p>
+        </p:txBody>
+      </p:sp>
+      <p:sp>
+        <p:nvSpPr>
+          <p:cNvPr id="10" name="Rectangle 9"/>
+          <p:cNvSpPr/>
+          <p:nvPr/>
+        </p:nvSpPr>
+        <p:spPr>
+          <a:xfrm>
+            <a:off x="5020056" y="2194560"/>
+            <a:ext cx="1965960" cy="2194560"/>
+          </a:xfrm>
+          <a:prstGeom prst="rect">
+            <a:avLst/>
+          </a:prstGeom>
+          <a:solidFill>
+            <a:srgbClr val="E76F51"/>
+          </a:solidFill>
+          <a:ln>
+            <a:noFill/>
+          </a:ln>
+        </p:spPr>
+        <p:style>
+          <a:lnRef idx="1">
+            <a:schemeClr val="accent1"/>
+          </a:lnRef>
+          <a:fillRef idx="3">
+            <a:schemeClr val="accent1"/>
+          </a:fillRef>
+          <a:effectRef idx="2">
+            <a:schemeClr val="accent1"/>
+          </a:effectRef>
+          <a:fontRef idx="minor">
+            <a:schemeClr val="lt1"/>
+          </a:fontRef>
+        </p:style>
+        <p:txBody>
+          <a:bodyPr rtlCol="0" anchor="ctr" wrap="square"/>
+          <a:lstStyle/>
+          <a:p>
+            <a:pPr algn="ctr">
+              <a:defRPr sz="1900" b="1">
+                <a:solidFill>
+                  <a:srgbClr val="FFFFFF"/>
+                </a:solidFill>
+              </a:defRPr>
+            </a:pPr>
+            <a:r>
+              <a:t>ADAPTIVE</a:t>
+            </a:r>
+            <a:br/>
+            <a:r>
+              <a:t>AVG POOL</a:t>
+            </a:r>
+          </a:p>
+          <a:p>
+            <a:pPr algn="ctr">
+              <a:defRPr sz="1400">
+                <a:solidFill>
+                  <a:srgbClr val="FFFFFF"/>
+                </a:solidFill>
+              </a:defRPr>
+            </a:pPr>
+            <a:r>
+              <a:t>4 × 8</a:t>
+            </a:r>
+            <a:br/>
+            <a:r>
+              <a:t>keeps time</a:t>
+            </a:r>
+            <a:br/>
+            <a:r>
+              <a:t>resolution</a:t>
+            </a:r>
+          </a:p>
+        </p:txBody>
+      </p:sp>
+      <p:sp>
+        <p:nvSpPr>
+          <p:cNvPr id="11" name="TextBox 10"/>
+          <p:cNvSpPr txBox="1"/>
+          <p:nvPr/>
+        </p:nvSpPr>
+        <p:spPr>
+          <a:xfrm>
+            <a:off x="6986016" y="3063240"/>
+            <a:ext cx="292608" cy="457200"/>
+          </a:xfrm>
+          <a:prstGeom prst="rect">
+            <a:avLst/>
+          </a:prstGeom>
+          <a:noFill/>
+        </p:spPr>
+        <p:txBody>
+          <a:bodyPr wrap="none">
+            <a:spAutoFit/>
+          </a:bodyPr>
+          <a:lstStyle/>
           <a:p>
             <a:pPr>
-              <a:spcAft>
-                <a:spcPts val="1400"/>
-              </a:spcAft>
-              <a:defRPr sz="2200">
-                <a:solidFill>
-                  <a:srgbClr val="595959"/>
-                </a:solidFill>
-                <a:latin typeface="Consolas"/>
-              </a:defRPr>
-            </a:pPr>
-            <a:r>
-              <a:t>Conv 64→128 (3×3) → BatchNorm → ReLU → MaxPool(2×2) → Dropout(0.25)</a:t>
-            </a:r>
-          </a:p>
+              <a:defRPr sz="2600">
+                <a:solidFill>
+                  <a:srgbClr val="E76F51"/>
+                </a:solidFill>
+              </a:defRPr>
+            </a:pPr>
+            <a:r>
+              <a:t>▶</a:t>
+            </a:r>
+          </a:p>
+        </p:txBody>
+      </p:sp>
+      <p:sp>
+        <p:nvSpPr>
+          <p:cNvPr id="12" name="Rectangle 11"/>
+          <p:cNvSpPr/>
+          <p:nvPr/>
+        </p:nvSpPr>
+        <p:spPr>
+          <a:xfrm>
+            <a:off x="7278624" y="2194560"/>
+            <a:ext cx="1965960" cy="2194560"/>
+          </a:xfrm>
+          <a:prstGeom prst="rect">
+            <a:avLst/>
+          </a:prstGeom>
+          <a:solidFill>
+            <a:srgbClr val="1F3A5F"/>
+          </a:solidFill>
+          <a:ln>
+            <a:noFill/>
+          </a:ln>
+        </p:spPr>
+        <p:style>
+          <a:lnRef idx="1">
+            <a:schemeClr val="accent1"/>
+          </a:lnRef>
+          <a:fillRef idx="3">
+            <a:schemeClr val="accent1"/>
+          </a:fillRef>
+          <a:effectRef idx="2">
+            <a:schemeClr val="accent1"/>
+          </a:effectRef>
+          <a:fontRef idx="minor">
+            <a:schemeClr val="lt1"/>
+          </a:fontRef>
+        </p:style>
+        <p:txBody>
+          <a:bodyPr rtlCol="0" anchor="ctr" wrap="square"/>
+          <a:lstStyle/>
+          <a:p>
+            <a:pPr algn="ctr">
+              <a:defRPr sz="1900" b="1">
+                <a:solidFill>
+                  <a:srgbClr val="FFFFFF"/>
+                </a:solidFill>
+              </a:defRPr>
+            </a:pPr>
+            <a:r>
+              <a:t>DENSE</a:t>
+            </a:r>
+          </a:p>
+          <a:p>
+            <a:pPr algn="ctr">
+              <a:defRPr sz="1400">
+                <a:solidFill>
+                  <a:srgbClr val="FFFFFF"/>
+                </a:solidFill>
+              </a:defRPr>
+            </a:pPr>
+            <a:r>
+              <a:t>4096 → 256</a:t>
+            </a:r>
+            <a:br/>
+            <a:r>
+              <a:t>ReLU + Dropout</a:t>
+            </a:r>
+            <a:br/>
+            <a:r>
+              <a:t>(0.5)</a:t>
+            </a:r>
+          </a:p>
+        </p:txBody>
+      </p:sp>
+      <p:sp>
+        <p:nvSpPr>
+          <p:cNvPr id="13" name="TextBox 12"/>
+          <p:cNvSpPr txBox="1"/>
+          <p:nvPr/>
+        </p:nvSpPr>
+        <p:spPr>
+          <a:xfrm>
+            <a:off x="9244584" y="3063240"/>
+            <a:ext cx="292608" cy="457200"/>
+          </a:xfrm>
+          <a:prstGeom prst="rect">
+            <a:avLst/>
+          </a:prstGeom>
+          <a:noFill/>
+        </p:spPr>
+        <p:txBody>
+          <a:bodyPr wrap="none">
+            <a:spAutoFit/>
+          </a:bodyPr>
+          <a:lstStyle/>
           <a:p>
             <a:pPr>
-              <a:spcAft>
-                <a:spcPts val="1400"/>
-              </a:spcAft>
-              <a:defRPr sz="2200">
-                <a:solidFill>
-                  <a:srgbClr val="595959"/>
-                </a:solidFill>
-                <a:latin typeface="Consolas"/>
-              </a:defRPr>
-            </a:pPr>
-            <a:r>
-              <a:t>AdaptiveAvgPool(4×8)  →  4096 features (keeps time resolution)</a:t>
-            </a:r>
-          </a:p>
-          <a:p>
-            <a:pPr>
-              <a:spcAft>
-                <a:spcPts val="1400"/>
-              </a:spcAft>
-              <a:defRPr sz="2200">
-                <a:solidFill>
-                  <a:srgbClr val="595959"/>
-                </a:solidFill>
-                <a:latin typeface="Consolas"/>
-              </a:defRPr>
-            </a:pPr>
-            <a:r>
-              <a:t>Linear 4096→256 → ReLU → Dropout(0.5) → Linear 256→35 → Softmax</a:t>
-            </a:r>
-          </a:p>
-        </p:txBody>
-      </p:sp>
-      <p:sp>
-        <p:nvSpPr>
-          <p:cNvPr id="6" name="TextBox 5"/>
+              <a:defRPr sz="2600">
+                <a:solidFill>
+                  <a:srgbClr val="E76F51"/>
+                </a:solidFill>
+              </a:defRPr>
+            </a:pPr>
+            <a:r>
+              <a:t>▶</a:t>
+            </a:r>
+          </a:p>
+        </p:txBody>
+      </p:sp>
+      <p:sp>
+        <p:nvSpPr>
+          <p:cNvPr id="14" name="Rectangle 13"/>
+          <p:cNvSpPr/>
+          <p:nvPr/>
+        </p:nvSpPr>
+        <p:spPr>
+          <a:xfrm>
+            <a:off x="9537192" y="2194560"/>
+            <a:ext cx="1965960" cy="2194560"/>
+          </a:xfrm>
+          <a:prstGeom prst="rect">
+            <a:avLst/>
+          </a:prstGeom>
+          <a:solidFill>
+            <a:srgbClr val="1F3A5F"/>
+          </a:solidFill>
+          <a:ln>
+            <a:noFill/>
+          </a:ln>
+        </p:spPr>
+        <p:style>
+          <a:lnRef idx="1">
+            <a:schemeClr val="accent1"/>
+          </a:lnRef>
+          <a:fillRef idx="3">
+            <a:schemeClr val="accent1"/>
+          </a:fillRef>
+          <a:effectRef idx="2">
+            <a:schemeClr val="accent1"/>
+          </a:effectRef>
+          <a:fontRef idx="minor">
+            <a:schemeClr val="lt1"/>
+          </a:fontRef>
+        </p:style>
+        <p:txBody>
+          <a:bodyPr rtlCol="0" anchor="ctr" wrap="square"/>
+          <a:lstStyle/>
+          <a:p>
+            <a:pPr algn="ctr">
+              <a:defRPr sz="1900" b="1">
+                <a:solidFill>
+                  <a:srgbClr val="FFFFFF"/>
+                </a:solidFill>
+              </a:defRPr>
+            </a:pPr>
+            <a:r>
+              <a:t>OUTPUT</a:t>
+            </a:r>
+          </a:p>
+          <a:p>
+            <a:pPr algn="ctr">
+              <a:defRPr sz="1400">
+                <a:solidFill>
+                  <a:srgbClr val="FFFFFF"/>
+                </a:solidFill>
+              </a:defRPr>
+            </a:pPr>
+            <a:r>
+              <a:t>35 words</a:t>
+            </a:r>
+            <a:br/>
+            <a:r>
+              <a:t>softmax</a:t>
+            </a:r>
+          </a:p>
+        </p:txBody>
+      </p:sp>
+      <p:sp>
+        <p:nvSpPr>
+          <p:cNvPr id="15" name="TextBox 14"/>
           <p:cNvSpPr txBox="1"/>
           <p:nvPr/>
         </p:nvSpPr>
         <p:spPr>
           <a:xfrm>
-            <a:off x="640080" y="5120640"/>
-            <a:ext cx="10881360" cy="1371600"/>
+            <a:off x="640080" y="4846320"/>
+            <a:ext cx="10881360" cy="1463040"/>
           </a:xfrm>
           <a:prstGeom prst="rect">
             <a:avLst/>
@@ -5284,6 +7546,56 @@
             </a:pPr>
             <a:r>
               <a:t>Convolutions detect local time-frequency patterns; pooling gives shift tolerance; dropout + batch-norm fight overfitting.</a:t>
+            </a:r>
+          </a:p>
+          <a:p>
+            <a:pPr>
+              <a:spcAft>
+                <a:spcPts val="1000"/>
+              </a:spcAft>
+              <a:defRPr sz="1800" b="1">
+                <a:solidFill>
+                  <a:srgbClr val="595959"/>
+                </a:solidFill>
+              </a:defRPr>
+            </a:pPr>
+            <a:r>
+              <a:t>The coral block is the hero of this story — more on the next slide.</a:t>
+            </a:r>
+          </a:p>
+        </p:txBody>
+      </p:sp>
+      <p:sp>
+        <p:nvSpPr>
+          <p:cNvPr id="16" name="TextBox 15"/>
+          <p:cNvSpPr txBox="1"/>
+          <p:nvPr/>
+        </p:nvSpPr>
+        <p:spPr>
+          <a:xfrm>
+            <a:off x="9692640" y="6446520"/>
+            <a:ext cx="2011680" cy="320040"/>
+          </a:xfrm>
+          <a:prstGeom prst="rect">
+            <a:avLst/>
+          </a:prstGeom>
+          <a:noFill/>
+        </p:spPr>
+        <p:txBody>
+          <a:bodyPr wrap="none">
+            <a:spAutoFit/>
+          </a:bodyPr>
+          <a:lstStyle/>
+          <a:p>
+            <a:pPr algn="r">
+              <a:defRPr sz="1100">
+                <a:solidFill>
+                  <a:srgbClr val="595959"/>
+                </a:solidFill>
+              </a:defRPr>
+            </a:pPr>
+            <a:r>
+              <a:t>voice-command-recognition  •  5/13</a:t>
             </a:r>
           </a:p>
         </p:txBody>
@@ -5359,7 +7671,50 @@
       </p:sp>
       <p:sp>
         <p:nvSpPr>
-          <p:cNvPr id="3" name="TextBox 2"/>
+          <p:cNvPr id="3" name="Rectangle 2"/>
+          <p:cNvSpPr/>
+          <p:nvPr/>
+        </p:nvSpPr>
+        <p:spPr>
+          <a:xfrm>
+            <a:off x="0" y="1051560"/>
+            <a:ext cx="12191695" cy="54864"/>
+          </a:xfrm>
+          <a:prstGeom prst="rect">
+            <a:avLst/>
+          </a:prstGeom>
+          <a:solidFill>
+            <a:srgbClr val="E76F51"/>
+          </a:solidFill>
+          <a:ln>
+            <a:noFill/>
+          </a:ln>
+        </p:spPr>
+        <p:style>
+          <a:lnRef idx="1">
+            <a:schemeClr val="accent1"/>
+          </a:lnRef>
+          <a:fillRef idx="3">
+            <a:schemeClr val="accent1"/>
+          </a:fillRef>
+          <a:effectRef idx="2">
+            <a:schemeClr val="accent1"/>
+          </a:effectRef>
+          <a:fontRef idx="minor">
+            <a:schemeClr val="lt1"/>
+          </a:fontRef>
+        </p:style>
+        <p:txBody>
+          <a:bodyPr rtlCol="0" anchor="ctr"/>
+          <a:lstStyle/>
+          <a:p>
+            <a:pPr algn="ctr"/>
+          </a:p>
+        </p:txBody>
+      </p:sp>
+      <p:sp>
+        <p:nvSpPr>
+          <p:cNvPr id="4" name="TextBox 3"/>
           <p:cNvSpPr txBox="1"/>
           <p:nvPr/>
         </p:nvSpPr>
@@ -5394,14 +7749,14 @@
       </p:sp>
       <p:sp>
         <p:nvSpPr>
-          <p:cNvPr id="4" name="TextBox 3"/>
+          <p:cNvPr id="5" name="TextBox 4"/>
           <p:cNvSpPr txBox="1"/>
           <p:nvPr/>
         </p:nvSpPr>
         <p:spPr>
           <a:xfrm>
             <a:off x="640080" y="2011680"/>
-            <a:ext cx="5029200" cy="4114800"/>
+            <a:ext cx="5852160" cy="4114800"/>
           </a:xfrm>
           <a:prstGeom prst="rect">
             <a:avLst/>
@@ -5413,6 +7768,21 @@
             <a:spAutoFit/>
           </a:bodyPr>
           <a:lstStyle/>
+          <a:p>
+            <a:pPr>
+              <a:spcAft>
+                <a:spcPts val="1000"/>
+              </a:spcAft>
+              <a:defRPr sz="2000" b="1">
+                <a:solidFill>
+                  <a:srgbClr val="595959"/>
+                </a:solidFill>
+              </a:defRPr>
+            </a:pPr>
+            <a:r>
+              <a:t>Cross-entropy loss, best checkpoint kept by validation accuracy — the test set was never touched during training.</a:t>
+            </a:r>
+          </a:p>
           <a:p>
             <a:pPr>
               <a:spcAft>
@@ -5425,7 +7795,7 @@
               </a:defRPr>
             </a:pPr>
             <a:r>
-              <a:t>Optimizer Adam (lr 1e-3), batch 256, cross-entropy loss, 15 epochs.</a:t>
+              <a:t>Augmentation-free baseline: the numbers ahead are from clean training only.</a:t>
             </a:r>
           </a:p>
           <a:p>
@@ -5443,34 +7813,235 @@
               <a:t>Learning rate halved automatically when validation accuracy plateaus.</a:t>
             </a:r>
           </a:p>
-          <a:p>
-            <a:pPr>
-              <a:spcAft>
-                <a:spcPts val="1000"/>
-              </a:spcAft>
-              <a:defRPr sz="2000" b="1">
+        </p:txBody>
+      </p:sp>
+      <p:sp>
+        <p:nvSpPr>
+          <p:cNvPr id="6" name="Rectangle 5"/>
+          <p:cNvSpPr/>
+          <p:nvPr/>
+        </p:nvSpPr>
+        <p:spPr>
+          <a:xfrm>
+            <a:off x="6949440" y="2103120"/>
+            <a:ext cx="2286000" cy="1737360"/>
+          </a:xfrm>
+          <a:prstGeom prst="rect">
+            <a:avLst/>
+          </a:prstGeom>
+          <a:solidFill>
+            <a:srgbClr val="2E86AB"/>
+          </a:solidFill>
+          <a:ln>
+            <a:noFill/>
+          </a:ln>
+        </p:spPr>
+        <p:style>
+          <a:lnRef idx="1">
+            <a:schemeClr val="accent1"/>
+          </a:lnRef>
+          <a:fillRef idx="3">
+            <a:schemeClr val="accent1"/>
+          </a:fillRef>
+          <a:effectRef idx="2">
+            <a:schemeClr val="accent1"/>
+          </a:effectRef>
+          <a:fontRef idx="minor">
+            <a:schemeClr val="lt1"/>
+          </a:fontRef>
+        </p:style>
+        <p:txBody>
+          <a:bodyPr rtlCol="0" anchor="ctr" wrap="square"/>
+          <a:lstStyle/>
+          <a:p>
+            <a:pPr algn="ctr">
+              <a:defRPr sz="4000" b="1">
+                <a:solidFill>
+                  <a:srgbClr val="FFFFFF"/>
+                </a:solidFill>
+              </a:defRPr>
+            </a:pPr>
+            <a:r>
+              <a:t>15</a:t>
+            </a:r>
+          </a:p>
+          <a:p>
+            <a:pPr algn="ctr">
+              <a:defRPr sz="1500">
+                <a:solidFill>
+                  <a:srgbClr val="FFFFFF"/>
+                </a:solidFill>
+              </a:defRPr>
+            </a:pPr>
+            <a:r>
+              <a:t>epochs</a:t>
+            </a:r>
+            <a:br/>
+            <a:r>
+              <a:t>CPU-only</a:t>
+            </a:r>
+          </a:p>
+        </p:txBody>
+      </p:sp>
+      <p:sp>
+        <p:nvSpPr>
+          <p:cNvPr id="7" name="Rectangle 6"/>
+          <p:cNvSpPr/>
+          <p:nvPr/>
+        </p:nvSpPr>
+        <p:spPr>
+          <a:xfrm>
+            <a:off x="9464040" y="2103120"/>
+            <a:ext cx="2286000" cy="1737360"/>
+          </a:xfrm>
+          <a:prstGeom prst="rect">
+            <a:avLst/>
+          </a:prstGeom>
+          <a:solidFill>
+            <a:srgbClr val="2E86AB"/>
+          </a:solidFill>
+          <a:ln>
+            <a:noFill/>
+          </a:ln>
+        </p:spPr>
+        <p:style>
+          <a:lnRef idx="1">
+            <a:schemeClr val="accent1"/>
+          </a:lnRef>
+          <a:fillRef idx="3">
+            <a:schemeClr val="accent1"/>
+          </a:fillRef>
+          <a:effectRef idx="2">
+            <a:schemeClr val="accent1"/>
+          </a:effectRef>
+          <a:fontRef idx="minor">
+            <a:schemeClr val="lt1"/>
+          </a:fontRef>
+        </p:style>
+        <p:txBody>
+          <a:bodyPr rtlCol="0" anchor="ctr" wrap="square"/>
+          <a:lstStyle/>
+          <a:p>
+            <a:pPr algn="ctr">
+              <a:defRPr sz="4000" b="1">
+                <a:solidFill>
+                  <a:srgbClr val="FFFFFF"/>
+                </a:solidFill>
+              </a:defRPr>
+            </a:pPr>
+            <a:r>
+              <a:t>256</a:t>
+            </a:r>
+          </a:p>
+          <a:p>
+            <a:pPr algn="ctr">
+              <a:defRPr sz="1500">
+                <a:solidFill>
+                  <a:srgbClr val="FFFFFF"/>
+                </a:solidFill>
+              </a:defRPr>
+            </a:pPr>
+            <a:r>
+              <a:t>batch size</a:t>
+            </a:r>
+          </a:p>
+        </p:txBody>
+      </p:sp>
+      <p:sp>
+        <p:nvSpPr>
+          <p:cNvPr id="8" name="Rectangle 7"/>
+          <p:cNvSpPr/>
+          <p:nvPr/>
+        </p:nvSpPr>
+        <p:spPr>
+          <a:xfrm>
+            <a:off x="6949440" y="4114800"/>
+            <a:ext cx="4800600" cy="1737360"/>
+          </a:xfrm>
+          <a:prstGeom prst="rect">
+            <a:avLst/>
+          </a:prstGeom>
+          <a:solidFill>
+            <a:srgbClr val="595959"/>
+          </a:solidFill>
+          <a:ln>
+            <a:noFill/>
+          </a:ln>
+        </p:spPr>
+        <p:style>
+          <a:lnRef idx="1">
+            <a:schemeClr val="accent1"/>
+          </a:lnRef>
+          <a:fillRef idx="3">
+            <a:schemeClr val="accent1"/>
+          </a:fillRef>
+          <a:effectRef idx="2">
+            <a:schemeClr val="accent1"/>
+          </a:effectRef>
+          <a:fontRef idx="minor">
+            <a:schemeClr val="lt1"/>
+          </a:fontRef>
+        </p:style>
+        <p:txBody>
+          <a:bodyPr rtlCol="0" anchor="ctr" wrap="square"/>
+          <a:lstStyle/>
+          <a:p>
+            <a:pPr algn="ctr">
+              <a:defRPr sz="2800" b="1">
+                <a:solidFill>
+                  <a:srgbClr val="FFFFFF"/>
+                </a:solidFill>
+              </a:defRPr>
+            </a:pPr>
+            <a:r>
+              <a:t>Adam  •  lr 1e-3</a:t>
+            </a:r>
+          </a:p>
+          <a:p>
+            <a:pPr algn="ctr">
+              <a:defRPr sz="1500">
+                <a:solidFill>
+                  <a:srgbClr val="FFFFFF"/>
+                </a:solidFill>
+              </a:defRPr>
+            </a:pPr>
+            <a:r>
+              <a:t>optimizer</a:t>
+            </a:r>
+          </a:p>
+        </p:txBody>
+      </p:sp>
+      <p:sp>
+        <p:nvSpPr>
+          <p:cNvPr id="9" name="TextBox 8"/>
+          <p:cNvSpPr txBox="1"/>
+          <p:nvPr/>
+        </p:nvSpPr>
+        <p:spPr>
+          <a:xfrm>
+            <a:off x="9692640" y="6446520"/>
+            <a:ext cx="2011680" cy="320040"/>
+          </a:xfrm>
+          <a:prstGeom prst="rect">
+            <a:avLst/>
+          </a:prstGeom>
+          <a:noFill/>
+        </p:spPr>
+        <p:txBody>
+          <a:bodyPr wrap="none">
+            <a:spAutoFit/>
+          </a:bodyPr>
+          <a:lstStyle/>
+          <a:p>
+            <a:pPr algn="r">
+              <a:defRPr sz="1100">
                 <a:solidFill>
                   <a:srgbClr val="595959"/>
                 </a:solidFill>
               </a:defRPr>
             </a:pPr>
             <a:r>
-              <a:t>Best checkpoint kept by validation accuracy — test set never touched during training.</a:t>
-            </a:r>
-          </a:p>
-          <a:p>
-            <a:pPr>
-              <a:spcAft>
-                <a:spcPts val="1000"/>
-              </a:spcAft>
-              <a:defRPr sz="2000" b="0">
-                <a:solidFill>
-                  <a:srgbClr val="595959"/>
-                </a:solidFill>
-              </a:defRPr>
-            </a:pPr>
-            <a:r>
-              <a:t>Augmentation-free baseline: the numbers below are from clean training only.</a:t>
+              <a:t>voice-command-recognition  •  6/13</a:t>
             </a:r>
           </a:p>
         </p:txBody>
@@ -5546,7 +8117,50 @@
       </p:sp>
       <p:sp>
         <p:nvSpPr>
-          <p:cNvPr id="3" name="TextBox 2"/>
+          <p:cNvPr id="3" name="Rectangle 2"/>
+          <p:cNvSpPr/>
+          <p:nvPr/>
+        </p:nvSpPr>
+        <p:spPr>
+          <a:xfrm>
+            <a:off x="0" y="1051560"/>
+            <a:ext cx="12191695" cy="54864"/>
+          </a:xfrm>
+          <a:prstGeom prst="rect">
+            <a:avLst/>
+          </a:prstGeom>
+          <a:solidFill>
+            <a:srgbClr val="E76F51"/>
+          </a:solidFill>
+          <a:ln>
+            <a:noFill/>
+          </a:ln>
+        </p:spPr>
+        <p:style>
+          <a:lnRef idx="1">
+            <a:schemeClr val="accent1"/>
+          </a:lnRef>
+          <a:fillRef idx="3">
+            <a:schemeClr val="accent1"/>
+          </a:fillRef>
+          <a:effectRef idx="2">
+            <a:schemeClr val="accent1"/>
+          </a:effectRef>
+          <a:fontRef idx="minor">
+            <a:schemeClr val="lt1"/>
+          </a:fontRef>
+        </p:style>
+        <p:txBody>
+          <a:bodyPr rtlCol="0" anchor="ctr"/>
+          <a:lstStyle/>
+          <a:p>
+            <a:pPr algn="ctr"/>
+          </a:p>
+        </p:txBody>
+      </p:sp>
+      <p:sp>
+        <p:nvSpPr>
+          <p:cNvPr id="4" name="TextBox 3"/>
           <p:cNvSpPr txBox="1"/>
           <p:nvPr/>
         </p:nvSpPr>
@@ -5581,13 +8195,13 @@
       </p:sp>
       <p:sp>
         <p:nvSpPr>
-          <p:cNvPr id="4" name="TextBox 3"/>
+          <p:cNvPr id="5" name="TextBox 4"/>
           <p:cNvSpPr txBox="1"/>
           <p:nvPr/>
         </p:nvSpPr>
         <p:spPr>
           <a:xfrm>
-            <a:off x="457200" y="1188720"/>
+            <a:off x="457200" y="1207008"/>
             <a:ext cx="11277295" cy="457200"/>
           </a:xfrm>
           <a:prstGeom prst="rect">
@@ -5616,14 +8230,224 @@
       </p:sp>
       <p:sp>
         <p:nvSpPr>
-          <p:cNvPr id="5" name="TextBox 4"/>
+          <p:cNvPr id="6" name="TextBox 5"/>
           <p:cNvSpPr txBox="1"/>
           <p:nvPr/>
         </p:nvSpPr>
         <p:spPr>
           <a:xfrm>
-            <a:off x="640080" y="2011680"/>
-            <a:ext cx="10881360" cy="4114800"/>
+            <a:off x="1463040" y="2011680"/>
+            <a:ext cx="2834640" cy="1280160"/>
+          </a:xfrm>
+          <a:prstGeom prst="rect">
+            <a:avLst/>
+          </a:prstGeom>
+          <a:noFill/>
+        </p:spPr>
+        <p:txBody>
+          <a:bodyPr wrap="none">
+            <a:spAutoFit/>
+          </a:bodyPr>
+          <a:lstStyle/>
+          <a:p>
+            <a:pPr algn="ctr">
+              <a:defRPr sz="6400" b="1">
+                <a:solidFill>
+                  <a:srgbClr val="595959"/>
+                </a:solidFill>
+              </a:defRPr>
+            </a:pPr>
+            <a:r>
+              <a:t>52.7%</a:t>
+            </a:r>
+          </a:p>
+        </p:txBody>
+      </p:sp>
+      <p:sp>
+        <p:nvSpPr>
+          <p:cNvPr id="7" name="TextBox 6"/>
+          <p:cNvSpPr txBox="1"/>
+          <p:nvPr/>
+        </p:nvSpPr>
+        <p:spPr>
+          <a:xfrm>
+            <a:off x="1463040" y="3200400"/>
+            <a:ext cx="2834640" cy="457200"/>
+          </a:xfrm>
+          <a:prstGeom prst="rect">
+            <a:avLst/>
+          </a:prstGeom>
+          <a:noFill/>
+        </p:spPr>
+        <p:txBody>
+          <a:bodyPr wrap="none">
+            <a:spAutoFit/>
+          </a:bodyPr>
+          <a:lstStyle/>
+          <a:p>
+            <a:pPr algn="ctr">
+              <a:defRPr sz="1600">
+                <a:solidFill>
+                  <a:srgbClr val="595959"/>
+                </a:solidFill>
+              </a:defRPr>
+            </a:pPr>
+            <a:r>
+              <a:t>first model</a:t>
+            </a:r>
+          </a:p>
+        </p:txBody>
+      </p:sp>
+      <p:sp>
+        <p:nvSpPr>
+          <p:cNvPr id="8" name="TextBox 7"/>
+          <p:cNvSpPr txBox="1"/>
+          <p:nvPr/>
+        </p:nvSpPr>
+        <p:spPr>
+          <a:xfrm>
+            <a:off x="7863840" y="2011680"/>
+            <a:ext cx="2834640" cy="1280160"/>
+          </a:xfrm>
+          <a:prstGeom prst="rect">
+            <a:avLst/>
+          </a:prstGeom>
+          <a:noFill/>
+        </p:spPr>
+        <p:txBody>
+          <a:bodyPr wrap="none">
+            <a:spAutoFit/>
+          </a:bodyPr>
+          <a:lstStyle/>
+          <a:p>
+            <a:pPr algn="ctr">
+              <a:defRPr sz="6400" b="1">
+                <a:solidFill>
+                  <a:srgbClr val="2E86AB"/>
+                </a:solidFill>
+              </a:defRPr>
+            </a:pPr>
+            <a:r>
+              <a:t>63.3%</a:t>
+            </a:r>
+          </a:p>
+        </p:txBody>
+      </p:sp>
+      <p:sp>
+        <p:nvSpPr>
+          <p:cNvPr id="9" name="TextBox 8"/>
+          <p:cNvSpPr txBox="1"/>
+          <p:nvPr/>
+        </p:nvSpPr>
+        <p:spPr>
+          <a:xfrm>
+            <a:off x="7863840" y="3200400"/>
+            <a:ext cx="2834640" cy="457200"/>
+          </a:xfrm>
+          <a:prstGeom prst="rect">
+            <a:avLst/>
+          </a:prstGeom>
+          <a:noFill/>
+        </p:spPr>
+        <p:txBody>
+          <a:bodyPr wrap="none">
+            <a:spAutoFit/>
+          </a:bodyPr>
+          <a:lstStyle/>
+          <a:p>
+            <a:pPr algn="ctr">
+              <a:defRPr sz="1600">
+                <a:solidFill>
+                  <a:srgbClr val="595959"/>
+                </a:solidFill>
+              </a:defRPr>
+            </a:pPr>
+            <a:r>
+              <a:t>after pooling fix</a:t>
+            </a:r>
+          </a:p>
+        </p:txBody>
+      </p:sp>
+      <p:sp>
+        <p:nvSpPr>
+          <p:cNvPr id="10" name="TextBox 9"/>
+          <p:cNvSpPr txBox="1"/>
+          <p:nvPr/>
+        </p:nvSpPr>
+        <p:spPr>
+          <a:xfrm>
+            <a:off x="5394960" y="2148840"/>
+            <a:ext cx="1463040" cy="1097280"/>
+          </a:xfrm>
+          <a:prstGeom prst="rect">
+            <a:avLst/>
+          </a:prstGeom>
+          <a:noFill/>
+        </p:spPr>
+        <p:txBody>
+          <a:bodyPr wrap="none">
+            <a:spAutoFit/>
+          </a:bodyPr>
+          <a:lstStyle/>
+          <a:p>
+            <a:pPr algn="ctr">
+              <a:defRPr sz="6400" b="1">
+                <a:solidFill>
+                  <a:srgbClr val="E76F51"/>
+                </a:solidFill>
+              </a:defRPr>
+            </a:pPr>
+            <a:r>
+              <a:t>▶</a:t>
+            </a:r>
+          </a:p>
+        </p:txBody>
+      </p:sp>
+      <p:sp>
+        <p:nvSpPr>
+          <p:cNvPr id="11" name="TextBox 10"/>
+          <p:cNvSpPr txBox="1"/>
+          <p:nvPr/>
+        </p:nvSpPr>
+        <p:spPr>
+          <a:xfrm>
+            <a:off x="5212080" y="3200400"/>
+            <a:ext cx="1828800" cy="457200"/>
+          </a:xfrm>
+          <a:prstGeom prst="rect">
+            <a:avLst/>
+          </a:prstGeom>
+          <a:noFill/>
+        </p:spPr>
+        <p:txBody>
+          <a:bodyPr wrap="none">
+            <a:spAutoFit/>
+          </a:bodyPr>
+          <a:lstStyle/>
+          <a:p>
+            <a:pPr algn="ctr">
+              <a:defRPr sz="1800" b="1">
+                <a:solidFill>
+                  <a:srgbClr val="E76F51"/>
+                </a:solidFill>
+              </a:defRPr>
+            </a:pPr>
+            <a:r>
+              <a:t>+10.6 points</a:t>
+            </a:r>
+          </a:p>
+        </p:txBody>
+      </p:sp>
+      <p:sp>
+        <p:nvSpPr>
+          <p:cNvPr id="12" name="TextBox 11"/>
+          <p:cNvSpPr txBox="1"/>
+          <p:nvPr/>
+        </p:nvSpPr>
+        <p:spPr>
+          <a:xfrm>
+            <a:off x="640080" y="4206240"/>
+            <a:ext cx="10881360" cy="2194560"/>
           </a:xfrm>
           <a:prstGeom prst="rect">
             <a:avLst/>
@@ -5640,7 +8464,7 @@
               <a:spcAft>
                 <a:spcPts val="1000"/>
               </a:spcAft>
-              <a:defRPr sz="2000" b="0">
+              <a:defRPr sz="1800" b="0">
                 <a:solidFill>
                   <a:srgbClr val="595959"/>
                 </a:solidFill>
@@ -5655,14 +8479,14 @@
               <a:spcAft>
                 <a:spcPts val="1000"/>
               </a:spcAft>
-              <a:defRPr sz="2000" b="0">
+              <a:defRPr sz="1800" b="0">
                 <a:solidFill>
                   <a:srgbClr val="595959"/>
                 </a:solidFill>
               </a:defRPr>
             </a:pPr>
             <a:r>
-              <a:t>Diagnosis: two stacked 2×2 max-pools crushed the 40×101 spectrogram down to 10×25, throwing away the fine timing detail that separates “three” from “tree”.</a:t>
+              <a:t>Diagnosis: two stacked 2×2 max-pools crushed the 40×101 spectrogram to 10×25, destroying the fine timing detail that separates “three” from “tree”.</a:t>
             </a:r>
           </a:p>
           <a:p>
@@ -5670,44 +8494,49 @@
               <a:spcAft>
                 <a:spcPts val="1000"/>
               </a:spcAft>
-              <a:defRPr sz="2000" b="1">
+              <a:defRPr sz="1800" b="1">
                 <a:solidFill>
                   <a:srgbClr val="595959"/>
                 </a:solidFill>
               </a:defRPr>
             </a:pPr>
             <a:r>
-              <a:t>Fix: replaced the aggressive pooling with AdaptiveAvgPool(4×8), keeping time-frequency resolution into the dense head.</a:t>
-            </a:r>
-          </a:p>
-          <a:p>
-            <a:pPr>
-              <a:spcAft>
-                <a:spcPts val="1000"/>
-              </a:spcAft>
-              <a:defRPr sz="2000" b="1">
+              <a:t>Viva-ready lesson: when a model underfits, ask what information the architecture destroys.</a:t>
+            </a:r>
+          </a:p>
+        </p:txBody>
+      </p:sp>
+      <p:sp>
+        <p:nvSpPr>
+          <p:cNvPr id="13" name="TextBox 12"/>
+          <p:cNvSpPr txBox="1"/>
+          <p:nvPr/>
+        </p:nvSpPr>
+        <p:spPr>
+          <a:xfrm>
+            <a:off x="9692640" y="6446520"/>
+            <a:ext cx="2011680" cy="320040"/>
+          </a:xfrm>
+          <a:prstGeom prst="rect">
+            <a:avLst/>
+          </a:prstGeom>
+          <a:noFill/>
+        </p:spPr>
+        <p:txBody>
+          <a:bodyPr wrap="none">
+            <a:spAutoFit/>
+          </a:bodyPr>
+          <a:lstStyle/>
+          <a:p>
+            <a:pPr algn="r">
+              <a:defRPr sz="1100">
                 <a:solidFill>
                   <a:srgbClr val="595959"/>
                 </a:solidFill>
               </a:defRPr>
             </a:pPr>
             <a:r>
-              <a:t>Result: 52.7% → 63.3% test accuracy (+10.6 points) on the same 15-epoch budget.</a:t>
-            </a:r>
-          </a:p>
-          <a:p>
-            <a:pPr>
-              <a:spcAft>
-                <a:spcPts val="1000"/>
-              </a:spcAft>
-              <a:defRPr sz="2000" b="0">
-                <a:solidFill>
-                  <a:srgbClr val="595959"/>
-                </a:solidFill>
-              </a:defRPr>
-            </a:pPr>
-            <a:r>
-              <a:t>Viva-ready lesson: when a model underfits, ask what information the architecture destroys.</a:t>
+              <a:t>voice-command-recognition  •  7/13</a:t>
             </a:r>
           </a:p>
         </p:txBody>
@@ -5783,7 +8612,50 @@
       </p:sp>
       <p:sp>
         <p:nvSpPr>
-          <p:cNvPr id="3" name="TextBox 2"/>
+          <p:cNvPr id="3" name="Rectangle 2"/>
+          <p:cNvSpPr/>
+          <p:nvPr/>
+        </p:nvSpPr>
+        <p:spPr>
+          <a:xfrm>
+            <a:off x="0" y="1051560"/>
+            <a:ext cx="12191695" cy="54864"/>
+          </a:xfrm>
+          <a:prstGeom prst="rect">
+            <a:avLst/>
+          </a:prstGeom>
+          <a:solidFill>
+            <a:srgbClr val="E76F51"/>
+          </a:solidFill>
+          <a:ln>
+            <a:noFill/>
+          </a:ln>
+        </p:spPr>
+        <p:style>
+          <a:lnRef idx="1">
+            <a:schemeClr val="accent1"/>
+          </a:lnRef>
+          <a:fillRef idx="3">
+            <a:schemeClr val="accent1"/>
+          </a:fillRef>
+          <a:effectRef idx="2">
+            <a:schemeClr val="accent1"/>
+          </a:effectRef>
+          <a:fontRef idx="minor">
+            <a:schemeClr val="lt1"/>
+          </a:fontRef>
+        </p:style>
+        <p:txBody>
+          <a:bodyPr rtlCol="0" anchor="ctr"/>
+          <a:lstStyle/>
+          <a:p>
+            <a:pPr algn="ctr"/>
+          </a:p>
+        </p:txBody>
+      </p:sp>
+      <p:sp>
+        <p:nvSpPr>
+          <p:cNvPr id="4" name="TextBox 3"/>
           <p:cNvSpPr txBox="1"/>
           <p:nvPr/>
         </p:nvSpPr>
@@ -5818,13 +8690,13 @@
       </p:sp>
       <p:sp>
         <p:nvSpPr>
-          <p:cNvPr id="4" name="TextBox 3"/>
+          <p:cNvPr id="5" name="TextBox 4"/>
           <p:cNvSpPr txBox="1"/>
           <p:nvPr/>
         </p:nvSpPr>
         <p:spPr>
           <a:xfrm>
-            <a:off x="457200" y="1188720"/>
+            <a:off x="457200" y="1207008"/>
             <a:ext cx="11277295" cy="457200"/>
           </a:xfrm>
           <a:prstGeom prst="rect">
@@ -5853,7 +8725,7 @@
       </p:sp>
       <p:sp>
         <p:nvSpPr>
-          <p:cNvPr id="5" name="Rectangle 4"/>
+          <p:cNvPr id="6" name="Rectangle 5"/>
           <p:cNvSpPr/>
           <p:nvPr/>
         </p:nvSpPr>
@@ -5896,7 +8768,7 @@
       </p:sp>
       <p:sp>
         <p:nvSpPr>
-          <p:cNvPr id="6" name="TextBox 5"/>
+          <p:cNvPr id="7" name="TextBox 6"/>
           <p:cNvSpPr txBox="1"/>
           <p:nvPr/>
         </p:nvSpPr>
@@ -5931,7 +8803,7 @@
       </p:sp>
       <p:sp>
         <p:nvSpPr>
-          <p:cNvPr id="7" name="TextBox 6"/>
+          <p:cNvPr id="8" name="TextBox 7"/>
           <p:cNvSpPr txBox="1"/>
           <p:nvPr/>
         </p:nvSpPr>
@@ -5966,7 +8838,7 @@
       </p:sp>
       <p:sp>
         <p:nvSpPr>
-          <p:cNvPr id="8" name="Rectangle 7"/>
+          <p:cNvPr id="9" name="Rectangle 8"/>
           <p:cNvSpPr/>
           <p:nvPr/>
         </p:nvSpPr>
@@ -6009,7 +8881,7 @@
       </p:sp>
       <p:sp>
         <p:nvSpPr>
-          <p:cNvPr id="9" name="TextBox 8"/>
+          <p:cNvPr id="10" name="TextBox 9"/>
           <p:cNvSpPr txBox="1"/>
           <p:nvPr/>
         </p:nvSpPr>
@@ -6044,7 +8916,7 @@
       </p:sp>
       <p:sp>
         <p:nvSpPr>
-          <p:cNvPr id="10" name="TextBox 9"/>
+          <p:cNvPr id="11" name="TextBox 10"/>
           <p:cNvSpPr txBox="1"/>
           <p:nvPr/>
         </p:nvSpPr>
@@ -6079,7 +8951,7 @@
       </p:sp>
       <p:sp>
         <p:nvSpPr>
-          <p:cNvPr id="11" name="Rectangle 10"/>
+          <p:cNvPr id="12" name="Rectangle 11"/>
           <p:cNvSpPr/>
           <p:nvPr/>
         </p:nvSpPr>
@@ -6122,7 +8994,7 @@
       </p:sp>
       <p:sp>
         <p:nvSpPr>
-          <p:cNvPr id="12" name="TextBox 11"/>
+          <p:cNvPr id="13" name="TextBox 12"/>
           <p:cNvSpPr txBox="1"/>
           <p:nvPr/>
         </p:nvSpPr>
@@ -6157,7 +9029,7 @@
       </p:sp>
       <p:sp>
         <p:nvSpPr>
-          <p:cNvPr id="13" name="TextBox 12"/>
+          <p:cNvPr id="14" name="TextBox 13"/>
           <p:cNvSpPr txBox="1"/>
           <p:nvPr/>
         </p:nvSpPr>
@@ -6192,7 +9064,7 @@
       </p:sp>
       <p:sp>
         <p:nvSpPr>
-          <p:cNvPr id="14" name="TextBox 13"/>
+          <p:cNvPr id="15" name="TextBox 14"/>
           <p:cNvSpPr txBox="1"/>
           <p:nvPr/>
         </p:nvSpPr>
@@ -6224,6 +9096,41 @@
             </a:pPr>
             <a:r>
               <a:t>The CNN beats the classical pipeline by a clear margin — this gap is what deep learning buys us here.</a:t>
+            </a:r>
+          </a:p>
+        </p:txBody>
+      </p:sp>
+      <p:sp>
+        <p:nvSpPr>
+          <p:cNvPr id="16" name="TextBox 15"/>
+          <p:cNvSpPr txBox="1"/>
+          <p:nvPr/>
+        </p:nvSpPr>
+        <p:spPr>
+          <a:xfrm>
+            <a:off x="9692640" y="6446520"/>
+            <a:ext cx="2011680" cy="320040"/>
+          </a:xfrm>
+          <a:prstGeom prst="rect">
+            <a:avLst/>
+          </a:prstGeom>
+          <a:noFill/>
+        </p:spPr>
+        <p:txBody>
+          <a:bodyPr wrap="none">
+            <a:spAutoFit/>
+          </a:bodyPr>
+          <a:lstStyle/>
+          <a:p>
+            <a:pPr algn="r">
+              <a:defRPr sz="1100">
+                <a:solidFill>
+                  <a:srgbClr val="595959"/>
+                </a:solidFill>
+              </a:defRPr>
+            </a:pPr>
+            <a:r>
+              <a:t>voice-command-recognition  •  8/13</a:t>
             </a:r>
           </a:p>
         </p:txBody>
@@ -6299,7 +9206,50 @@
       </p:sp>
       <p:sp>
         <p:nvSpPr>
-          <p:cNvPr id="3" name="TextBox 2"/>
+          <p:cNvPr id="3" name="Rectangle 2"/>
+          <p:cNvSpPr/>
+          <p:nvPr/>
+        </p:nvSpPr>
+        <p:spPr>
+          <a:xfrm>
+            <a:off x="0" y="1051560"/>
+            <a:ext cx="12191695" cy="54864"/>
+          </a:xfrm>
+          <a:prstGeom prst="rect">
+            <a:avLst/>
+          </a:prstGeom>
+          <a:solidFill>
+            <a:srgbClr val="E76F51"/>
+          </a:solidFill>
+          <a:ln>
+            <a:noFill/>
+          </a:ln>
+        </p:spPr>
+        <p:style>
+          <a:lnRef idx="1">
+            <a:schemeClr val="accent1"/>
+          </a:lnRef>
+          <a:fillRef idx="3">
+            <a:schemeClr val="accent1"/>
+          </a:fillRef>
+          <a:effectRef idx="2">
+            <a:schemeClr val="accent1"/>
+          </a:effectRef>
+          <a:fontRef idx="minor">
+            <a:schemeClr val="lt1"/>
+          </a:fontRef>
+        </p:style>
+        <p:txBody>
+          <a:bodyPr rtlCol="0" anchor="ctr"/>
+          <a:lstStyle/>
+          <a:p>
+            <a:pPr algn="ctr"/>
+          </a:p>
+        </p:txBody>
+      </p:sp>
+      <p:sp>
+        <p:nvSpPr>
+          <p:cNvPr id="4" name="TextBox 3"/>
           <p:cNvSpPr txBox="1"/>
           <p:nvPr/>
         </p:nvSpPr>
@@ -6334,7 +9284,7 @@
       </p:sp>
       <p:pic>
         <p:nvPicPr>
-          <p:cNvPr id="4" name="Picture 3" descr="confusion_matrix.png"/>
+          <p:cNvPr id="5" name="Picture 4" descr="confusion_matrix.png"/>
           <p:cNvPicPr>
             <a:picLocks noChangeAspect="1"/>
           </p:cNvPicPr>
@@ -6358,7 +9308,7 @@
       </p:pic>
       <p:sp>
         <p:nvSpPr>
-          <p:cNvPr id="5" name="TextBox 4"/>
+          <p:cNvPr id="6" name="TextBox 5"/>
           <p:cNvSpPr txBox="1"/>
           <p:nvPr/>
         </p:nvSpPr>
@@ -6480,6 +9430,41 @@
             </a:pPr>
             <a:r>
               <a:t>These are genuinely similar-sounding words — even humans mix them up.</a:t>
+            </a:r>
+          </a:p>
+        </p:txBody>
+      </p:sp>
+      <p:sp>
+        <p:nvSpPr>
+          <p:cNvPr id="7" name="TextBox 6"/>
+          <p:cNvSpPr txBox="1"/>
+          <p:nvPr/>
+        </p:nvSpPr>
+        <p:spPr>
+          <a:xfrm>
+            <a:off x="9692640" y="6446520"/>
+            <a:ext cx="2011680" cy="320040"/>
+          </a:xfrm>
+          <a:prstGeom prst="rect">
+            <a:avLst/>
+          </a:prstGeom>
+          <a:noFill/>
+        </p:spPr>
+        <p:txBody>
+          <a:bodyPr wrap="none">
+            <a:spAutoFit/>
+          </a:bodyPr>
+          <a:lstStyle/>
+          <a:p>
+            <a:pPr algn="r">
+              <a:defRPr sz="1100">
+                <a:solidFill>
+                  <a:srgbClr val="595959"/>
+                </a:solidFill>
+              </a:defRPr>
+            </a:pPr>
+            <a:r>
+              <a:t>voice-command-recognition  •  9/13</a:t>
             </a:r>
           </a:p>
         </p:txBody>
@@ -6810,4 +9795,324 @@
   </a:objectDefaults>
   <a:extraClrSchemeLst/>
 </a:theme>
+</file>
+
+<file path=ppt/theme/theme2.xml><?xml version="1.0" encoding="utf-8"?>
+<a:theme xmlns:a="http://schemas.openxmlformats.org/drawingml/2006/main" name="Office Theme">
+  <a:themeElements>
+    <a:clrScheme name="Office">
+      <a:dk1>
+        <a:sysClr val="windowText" lastClr="000000"/>
+      </a:dk1>
+      <a:lt1>
+        <a:sysClr val="window" lastClr="FFFFFF"/>
+      </a:lt1>
+      <a:dk2>
+        <a:srgbClr val="1F497D"/>
+      </a:dk2>
+      <a:lt2>
+        <a:srgbClr val="EEECE1"/>
+      </a:lt2>
+      <a:accent1>
+        <a:srgbClr val="4F81BD"/>
+      </a:accent1>
+      <a:accent2>
+        <a:srgbClr val="C0504D"/>
+      </a:accent2>
+      <a:accent3>
+        <a:srgbClr val="9BBB59"/>
+      </a:accent3>
+      <a:accent4>
+        <a:srgbClr val="8064A2"/>
+      </a:accent4>
+      <a:accent5>
+        <a:srgbClr val="4BACC6"/>
+      </a:accent5>
+      <a:accent6>
+        <a:srgbClr val="F79646"/>
+      </a:accent6>
+      <a:hlink>
+        <a:srgbClr val="0000FF"/>
+      </a:hlink>
+      <a:folHlink>
+        <a:srgbClr val="800080"/>
+      </a:folHlink>
+    </a:clrScheme>
+    <a:fontScheme name="Office">
+      <a:majorFont>
+        <a:latin typeface="Calibri"/>
+        <a:ea typeface=""/>
+        <a:cs typeface=""/>
+        <a:font script="Jpan" typeface="ＭＳ Ｐゴシック"/>
+        <a:font script="Hang" typeface="맑은 고딕"/>
+        <a:font script="Hans" typeface="宋体"/>
+        <a:font script="Hant" typeface="新細明體"/>
+        <a:font script="Arab" typeface="Times New Roman"/>
+        <a:font script="Hebr" typeface="Times New Roman"/>
+        <a:font script="Thai" typeface="Angsana New"/>
+        <a:font script="Ethi" typeface="Nyala"/>
+        <a:font script="Beng" typeface="Vrinda"/>
+        <a:font script="Gujr" typeface="Shruti"/>
+        <a:font script="Khmr" typeface="MoolBoran"/>
+        <a:font script="Knda" typeface="Tunga"/>
+        <a:font script="Guru" typeface="Raavi"/>
+        <a:font script="Cans" typeface="Euphemia"/>
+        <a:font script="Cher" typeface="Plantagenet Cherokee"/>
+        <a:font script="Yiii" typeface="Microsoft Yi Baiti"/>
+        <a:font script="Tibt" typeface="Microsoft Himalaya"/>
+        <a:font script="Thaa" typeface="MV Boli"/>
+        <a:font script="Deva" typeface="Mangal"/>
+        <a:font script="Telu" typeface="Gautami"/>
+        <a:font script="Taml" typeface="Latha"/>
+        <a:font script="Syrc" typeface="Estrangelo Edessa"/>
+        <a:font script="Orya" typeface="Kalinga"/>
+        <a:font script="Mlym" typeface="Kartika"/>
+        <a:font script="Laoo" typeface="DokChampa"/>
+        <a:font script="Sinh" typeface="Iskoola Pota"/>
+        <a:font script="Mong" typeface="Mongolian Baiti"/>
+        <a:font script="Viet" typeface="Times New Roman"/>
+        <a:font script="Uigh" typeface="Microsoft Uighur"/>
+        <a:font script="Geor" typeface="Sylfaen"/>
+      </a:majorFont>
+      <a:minorFont>
+        <a:latin typeface="Calibri"/>
+        <a:ea typeface=""/>
+        <a:cs typeface=""/>
+        <a:font script="Jpan" typeface="ＭＳ Ｐゴシック"/>
+        <a:font script="Hang" typeface="맑은 고딕"/>
+        <a:font script="Hans" typeface="宋体"/>
+        <a:font script="Hant" typeface="新細明體"/>
+        <a:font script="Arab" typeface="Arial"/>
+        <a:font script="Hebr" typeface="Arial"/>
+        <a:font script="Thai" typeface="Cordia New"/>
+        <a:font script="Ethi" typeface="Nyala"/>
+        <a:font script="Beng" typeface="Vrinda"/>
+        <a:font script="Gujr" typeface="Shruti"/>
+        <a:font script="Khmr" typeface="DaunPenh"/>
+        <a:font script="Knda" typeface="Tunga"/>
+        <a:font script="Guru" typeface="Raavi"/>
+        <a:font script="Cans" typeface="Euphemia"/>
+        <a:font script="Cher" typeface="Plantagenet Cherokee"/>
+        <a:font script="Yiii" typeface="Microsoft Yi Baiti"/>
+        <a:font script="Tibt" typeface="Microsoft Himalaya"/>
+        <a:font script="Thaa" typeface="MV Boli"/>
+        <a:font script="Deva" typeface="Mangal"/>
+        <a:font script="Telu" typeface="Gautami"/>
+        <a:font script="Taml" typeface="Latha"/>
+        <a:font script="Syrc" typeface="Estrangelo Edessa"/>
+        <a:font script="Orya" typeface="Kalinga"/>
+        <a:font script="Mlym" typeface="Kartika"/>
+        <a:font script="Laoo" typeface="DokChampa"/>
+        <a:font script="Sinh" typeface="Iskoola Pota"/>
+        <a:font script="Mong" typeface="Mongolian Baiti"/>
+        <a:font script="Viet" typeface="Arial"/>
+        <a:font script="Uigh" typeface="Microsoft Uighur"/>
+        <a:font script="Geor" typeface="Sylfaen"/>
+      </a:minorFont>
+    </a:fontScheme>
+    <a:fmtScheme name="Office">
+      <a:fillStyleLst>
+        <a:solidFill>
+          <a:schemeClr val="phClr"/>
+        </a:solidFill>
+        <a:gradFill rotWithShape="1">
+          <a:gsLst>
+            <a:gs pos="0">
+              <a:schemeClr val="phClr">
+                <a:tint val="50000"/>
+                <a:satMod val="300000"/>
+              </a:schemeClr>
+            </a:gs>
+            <a:gs pos="35000">
+              <a:schemeClr val="phClr">
+                <a:tint val="37000"/>
+                <a:satMod val="300000"/>
+              </a:schemeClr>
+            </a:gs>
+            <a:gs pos="100000">
+              <a:schemeClr val="phClr">
+                <a:tint val="15000"/>
+                <a:satMod val="350000"/>
+              </a:schemeClr>
+            </a:gs>
+          </a:gsLst>
+          <a:lin ang="16200000" scaled="1"/>
+        </a:gradFill>
+        <a:gradFill rotWithShape="1">
+          <a:gsLst>
+            <a:gs pos="0">
+              <a:schemeClr val="phClr">
+                <a:tint val="100000"/>
+                <a:shade val="100000"/>
+                <a:satMod val="130000"/>
+              </a:schemeClr>
+            </a:gs>
+            <a:gs pos="100000">
+              <a:schemeClr val="phClr">
+                <a:tint val="50000"/>
+                <a:shade val="100000"/>
+                <a:satMod val="350000"/>
+              </a:schemeClr>
+            </a:gs>
+          </a:gsLst>
+          <a:lin ang="16200000" scaled="0"/>
+        </a:gradFill>
+      </a:fillStyleLst>
+      <a:lnStyleLst>
+        <a:ln w="9525" cap="flat" cmpd="sng" algn="ctr">
+          <a:solidFill>
+            <a:schemeClr val="phClr">
+              <a:shade val="95000"/>
+              <a:satMod val="105000"/>
+            </a:schemeClr>
+          </a:solidFill>
+          <a:prstDash val="solid"/>
+        </a:ln>
+        <a:ln w="25400" cap="flat" cmpd="sng" algn="ctr">
+          <a:solidFill>
+            <a:schemeClr val="phClr"/>
+          </a:solidFill>
+          <a:prstDash val="solid"/>
+        </a:ln>
+        <a:ln w="38100" cap="flat" cmpd="sng" algn="ctr">
+          <a:solidFill>
+            <a:schemeClr val="phClr"/>
+          </a:solidFill>
+          <a:prstDash val="solid"/>
+        </a:ln>
+      </a:lnStyleLst>
+      <a:effectStyleLst>
+        <a:effectStyle>
+          <a:effectLst>
+            <a:outerShdw blurRad="40000" dist="20000" dir="5400000" rotWithShape="0">
+              <a:srgbClr val="000000">
+                <a:alpha val="38000"/>
+              </a:srgbClr>
+            </a:outerShdw>
+          </a:effectLst>
+        </a:effectStyle>
+        <a:effectStyle>
+          <a:effectLst>
+            <a:outerShdw blurRad="40000" dist="23000" dir="5400000" rotWithShape="0">
+              <a:srgbClr val="000000">
+                <a:alpha val="35000"/>
+              </a:srgbClr>
+            </a:outerShdw>
+          </a:effectLst>
+        </a:effectStyle>
+        <a:effectStyle>
+          <a:effectLst>
+            <a:outerShdw blurRad="40000" dist="23000" dir="5400000" rotWithShape="0">
+              <a:srgbClr val="000000">
+                <a:alpha val="35000"/>
+              </a:srgbClr>
+            </a:outerShdw>
+          </a:effectLst>
+          <a:scene3d>
+            <a:camera prst="orthographicFront">
+              <a:rot lat="0" lon="0" rev="0"/>
+            </a:camera>
+            <a:lightRig rig="threePt" dir="t">
+              <a:rot lat="0" lon="0" rev="1200000"/>
+            </a:lightRig>
+          </a:scene3d>
+          <a:sp3d>
+            <a:bevelT w="63500" h="25400"/>
+          </a:sp3d>
+        </a:effectStyle>
+      </a:effectStyleLst>
+      <a:bgFillStyleLst>
+        <a:solidFill>
+          <a:schemeClr val="phClr"/>
+        </a:solidFill>
+        <a:gradFill rotWithShape="1">
+          <a:gsLst>
+            <a:gs pos="0">
+              <a:schemeClr val="phClr">
+                <a:tint val="40000"/>
+                <a:satMod val="350000"/>
+              </a:schemeClr>
+            </a:gs>
+            <a:gs pos="40000">
+              <a:schemeClr val="phClr">
+                <a:tint val="45000"/>
+                <a:shade val="99000"/>
+                <a:satMod val="350000"/>
+              </a:schemeClr>
+            </a:gs>
+            <a:gs pos="100000">
+              <a:schemeClr val="phClr">
+                <a:shade val="20000"/>
+                <a:satMod val="255000"/>
+              </a:schemeClr>
+            </a:gs>
+          </a:gsLst>
+          <a:path path="circle">
+            <a:fillToRect l="50000" t="-80000" r="50000" b="180000"/>
+          </a:path>
+        </a:gradFill>
+        <a:gradFill rotWithShape="1">
+          <a:gsLst>
+            <a:gs pos="0">
+              <a:schemeClr val="phClr">
+                <a:tint val="80000"/>
+                <a:satMod val="300000"/>
+              </a:schemeClr>
+            </a:gs>
+            <a:gs pos="100000">
+              <a:schemeClr val="phClr">
+                <a:shade val="30000"/>
+                <a:satMod val="200000"/>
+              </a:schemeClr>
+            </a:gs>
+          </a:gsLst>
+          <a:path path="circle">
+            <a:fillToRect l="50000" t="50000" r="50000" b="50000"/>
+          </a:path>
+        </a:gradFill>
+      </a:bgFillStyleLst>
+    </a:fmtScheme>
+  </a:themeElements>
+  <a:objectDefaults>
+    <a:spDef>
+      <a:spPr/>
+      <a:bodyPr/>
+      <a:lstStyle/>
+      <a:style>
+        <a:lnRef idx="1">
+          <a:schemeClr val="accent1"/>
+        </a:lnRef>
+        <a:fillRef idx="3">
+          <a:schemeClr val="accent1"/>
+        </a:fillRef>
+        <a:effectRef idx="2">
+          <a:schemeClr val="accent1"/>
+        </a:effectRef>
+        <a:fontRef idx="minor">
+          <a:schemeClr val="lt1"/>
+        </a:fontRef>
+      </a:style>
+    </a:spDef>
+    <a:lnDef>
+      <a:spPr/>
+      <a:bodyPr/>
+      <a:lstStyle/>
+      <a:style>
+        <a:lnRef idx="2">
+          <a:schemeClr val="accent1"/>
+        </a:lnRef>
+        <a:fillRef idx="0">
+          <a:schemeClr val="accent1"/>
+        </a:fillRef>
+        <a:effectRef idx="1">
+          <a:schemeClr val="accent1"/>
+        </a:effectRef>
+        <a:fontRef idx="minor">
+          <a:schemeClr val="tx1"/>
+        </a:fontRef>
+      </a:style>
+    </a:lnDef>
+  </a:objectDefaults>
+  <a:extraClrSchemeLst/>
+</a:theme>
 </file>
</xml_diff>